<commit_message>
Clearer career chart, unstretched deck images, and Mead's batted balls on Fenway
- Career-years chart redesigned for instant reading: arrows from career
  average to 2026 (green better, red worse), delta labels, BEST OF
  CAREER badges; the three-symbol dumbbell encoding is gone
- Deck image stretching fixed at the root: the builder now reads each
  PNG's true dimensions instead of a hardcoded aspect table, so no
  figure can render distorted again
- New Fenway overlay (fig 19): Mead's 2026 batted balls mapped to field
  coordinates and drawn over Fenway's actual wall dimensions with the
  Monster highlighted. Verdict: 11 air balls to left reached wall depth
  (300-380 ft) without leaving the parks he played in, 5 of them caught;
  at Fenway that contact lives on the Monster. Wired into the article
  (with the approximate-coordinates caveat), the deck's Mead slide, and
  dark variants; acquisition.json carries the counts

Co-Authored-By: Claude Fable 5 <noreply@anthropic.com>
</commit_message>
<xml_diff>
--- a/outputs/Red_Sox_Trade_Deadline.pptx
+++ b/outputs/Red_Sox_Trade_Deadline.pptx
@@ -3471,8 +3471,8 @@
         </p:blipFill>
         <p:spPr>
           <a:xfrm>
-            <a:off x="490118" y="1554480"/>
-            <a:ext cx="7066483" cy="4206240"/>
+            <a:off x="615189" y="1554480"/>
+            <a:ext cx="6816340" cy="4206240"/>
           </a:xfrm>
           <a:prstGeom prst="rect">
             <a:avLst/>
@@ -4085,7 +4085,7 @@
         <p:spPr>
           <a:xfrm>
             <a:off x="365760" y="1600200"/>
-            <a:ext cx="7315200" cy="3593431"/>
+            <a:ext cx="7315200" cy="3546849"/>
           </a:xfrm>
           <a:prstGeom prst="rect">
             <a:avLst/>
@@ -4590,8 +4590,8 @@
         </p:blipFill>
         <p:spPr>
           <a:xfrm>
-            <a:off x="518160" y="1554480"/>
-            <a:ext cx="7010399" cy="4206240"/>
+            <a:off x="365760" y="1554480"/>
+            <a:ext cx="7315200" cy="3556000"/>
           </a:xfrm>
           <a:prstGeom prst="rect">
             <a:avLst/>
@@ -5990,7 +5990,7 @@
       </p:sp>
       <p:pic>
         <p:nvPicPr>
-          <p:cNvPr id="4" name="Picture 3" descr="18_mead_fit.png"/>
+          <p:cNvPr id="4" name="Picture 3" descr="19_mead_fenway.png"/>
           <p:cNvPicPr>
             <a:picLocks noChangeAspect="1"/>
           </p:cNvPicPr>
@@ -6004,8 +6004,8 @@
         </p:blipFill>
         <p:spPr>
           <a:xfrm>
-            <a:off x="365760" y="1554480"/>
-            <a:ext cx="7315200" cy="3018971"/>
+            <a:off x="822640" y="1481328"/>
+            <a:ext cx="6401438" cy="4572000"/>
           </a:xfrm>
           <a:prstGeom prst="rect">
             <a:avLst/>
@@ -9420,8 +9420,8 @@
         </p:blipFill>
         <p:spPr>
           <a:xfrm>
-            <a:off x="616305" y="1554480"/>
-            <a:ext cx="6814108" cy="4206240"/>
+            <a:off x="647113" y="1554480"/>
+            <a:ext cx="6752492" cy="4206240"/>
           </a:xfrm>
           <a:prstGeom prst="rect">
             <a:avLst/>
@@ -11885,7 +11885,7 @@
         <p:spPr>
           <a:xfrm>
             <a:off x="457200" y="1600200"/>
-            <a:ext cx="6309360" cy="3943350"/>
+            <a:ext cx="6309360" cy="3722378"/>
           </a:xfrm>
           <a:prstGeom prst="rect">
             <a:avLst/>
@@ -12540,7 +12540,7 @@
         <p:spPr>
           <a:xfrm>
             <a:off x="365760" y="1554480"/>
-            <a:ext cx="7589520" cy="3274998"/>
+            <a:ext cx="7589520" cy="3254824"/>
           </a:xfrm>
           <a:prstGeom prst="rect">
             <a:avLst/>
@@ -13017,8 +13017,8 @@
         </p:blipFill>
         <p:spPr>
           <a:xfrm>
-            <a:off x="1597621" y="1554480"/>
-            <a:ext cx="8993709" cy="2926080"/>
+            <a:off x="1535538" y="1554480"/>
+            <a:ext cx="9117874" cy="2926080"/>
           </a:xfrm>
           <a:prstGeom prst="rect">
             <a:avLst/>
@@ -13625,8 +13625,8 @@
         </p:blipFill>
         <p:spPr>
           <a:xfrm>
-            <a:off x="2811779" y="1508760"/>
-            <a:ext cx="6583680" cy="4114800"/>
+            <a:off x="2788920" y="1508760"/>
+            <a:ext cx="6629400" cy="3923110"/>
           </a:xfrm>
           <a:prstGeom prst="rect">
             <a:avLst/>

</xml_diff>

<commit_message>
AAAA cohort cut to the five still with the club
- Active-roster cut applied per the user's call: Seigler, Monasterio,
  Cheng, Guerrero, Moran. The season-long sweep had kept players since
  optioned, DFA'd, or on the 60-day IL
- Summary recomputed: 5 players, +1.3 WAR, 1 career best (Guerrero),
  2 rookies; article, memo, deck cards, and figure headline all track
  the new counts with singular/plural handled at any n
- Career chart height now scales with cohort size so a small cohort
  doesn't float in whitespace; example-sentence joiner fixed when only
  pen examples exist
- The 2016-2025 base rate is unchanged (league history, not roster
  dependent) and still anchors the regression case

Co-Authored-By: Claude Fable 5 <noreply@anthropic.com>
</commit_message>
<xml_diff>
--- a/outputs/Red_Sox_Trade_Deadline.pptx
+++ b/outputs/Red_Sox_Trade_Deadline.pptx
@@ -4086,7 +4086,7 @@
         <p:spPr>
           <a:xfrm>
             <a:off x="365760" y="1600200"/>
-            <a:ext cx="7315200" cy="3546849"/>
+            <a:ext cx="7315200" cy="2776987"/>
           </a:xfrm>
           <a:prstGeom prst="rect">
             <a:avLst/>
@@ -4176,7 +4176,7 @@
                 </a:solidFill>
                 <a:latin typeface="Arial"/>
               </a:rPr>
-              <a:t>15 AAAA contributors</a:t>
+              <a:t>5 AAAA contributors on the roster</a:t>
             </a:r>
           </a:p>
           <a:p>
@@ -4195,7 +4195,7 @@
                 </a:solidFill>
                 <a:latin typeface="Arial"/>
               </a:rPr>
-              <a:t>Waiver claims, up-down arms and career minor-leaguers holding real roles, +3.4 WAR combined.</a:t>
+              <a:t>Waiver claims, up-down arms and career minor-leaguers holding real roles, +1.3 WAR combined.</a:t>
             </a:r>
           </a:p>
         </p:txBody>
@@ -4283,7 +4283,7 @@
                 </a:solidFill>
                 <a:latin typeface="Arial"/>
               </a:rPr>
-              <a:t>4 career bests, 4 rookies</a:t>
+              <a:t>1 career best, 2 rookies</a:t>
             </a:r>
           </a:p>
           <a:p>
@@ -4302,7 +4302,7 @@
                 </a:solidFill>
                 <a:latin typeface="Arial"/>
               </a:rPr>
-              <a:t>Most of the vets are beating every season they've ever had; the rookies have no baseline at all.</a:t>
+              <a:t>The vets are beating their own track records; the rookies have no baseline at all.</a:t>
             </a:r>
           </a:p>
         </p:txBody>

</xml_diff>

<commit_message>
Regression watch: Cheng on the chart, hot regulars added (Contreras, Rafaela)
- Cheng now appears on the career chart as a marked rookie dot with
  'no baseline' label instead of being silently filtered
- New tier two in the audit: every regular (200+ PA, 800+ career PA)
  screened against the same 40-OPS-point yardstick as the backtest.
  Catches Contreras (+130 pts over career at 31, a career best) and
  Rafaela (+76, career best); the screen clears Abreu (-25 vs career),
  Yoshida and Duran, stated in the article for honesty
- Fig 17 is now 'The regression watch' with a divider band between the
  AAAA five and the hot regulars; article gets the tier-two paragraph
  (regression to a good career level, not a cliff), memo gets the
  regulars table, deck AAAA slide gets a fifth compact card
- For established players the deadline read stays: plan for good, not
  scorching, September production

Co-Authored-By: Claude Fable 5 <noreply@anthropic.com>
</commit_message>
<xml_diff>
--- a/outputs/Red_Sox_Trade_Deadline.pptx
+++ b/outputs/Red_Sox_Trade_Deadline.pptx
@@ -4086,7 +4086,7 @@
         <p:spPr>
           <a:xfrm>
             <a:off x="365760" y="1600200"/>
-            <a:ext cx="7315200" cy="2776987"/>
+            <a:ext cx="7315200" cy="3257028"/>
           </a:xfrm>
           <a:prstGeom prst="rect">
             <a:avLst/>
@@ -4101,8 +4101,8 @@
         </p:nvSpPr>
         <p:spPr>
           <a:xfrm>
-            <a:off x="8001000" y="1773936"/>
-            <a:ext cx="146304" cy="146304"/>
+            <a:off x="8001000" y="1664208"/>
+            <a:ext cx="137160" cy="137160"/>
           </a:xfrm>
           <a:prstGeom prst="roundRect">
             <a:avLst>
@@ -4147,30 +4147,30 @@
         </p:nvSpPr>
         <p:spPr>
           <a:xfrm>
-            <a:off x="8293608" y="1737360"/>
-            <a:ext cx="3749039" cy="1097280"/>
-          </a:xfrm>
-          <a:prstGeom prst="rect">
-            <a:avLst/>
-          </a:prstGeom>
-          <a:noFill/>
-        </p:spPr>
-        <p:txBody>
-          <a:bodyPr wrap="square" anchor="t" lIns="0" rIns="0" tIns="0" bIns="0">
-            <a:spAutoFit/>
-          </a:bodyPr>
-          <a:lstStyle/>
-          <a:p>
-            <a:pPr algn="l">
-              <a:lnSpc>
-                <a:spcPct val="107000"/>
-              </a:lnSpc>
-              <a:spcAft>
-                <a:spcPts val="200"/>
-              </a:spcAft>
-            </a:pPr>
-            <a:r>
-              <a:rPr sz="1350" b="1" i="0">
+            <a:off x="8293608" y="1627632"/>
+            <a:ext cx="3749039" cy="1005840"/>
+          </a:xfrm>
+          <a:prstGeom prst="rect">
+            <a:avLst/>
+          </a:prstGeom>
+          <a:noFill/>
+        </p:spPr>
+        <p:txBody>
+          <a:bodyPr wrap="square" anchor="t" lIns="0" rIns="0" tIns="0" bIns="0">
+            <a:spAutoFit/>
+          </a:bodyPr>
+          <a:lstStyle/>
+          <a:p>
+            <a:pPr algn="l">
+              <a:lnSpc>
+                <a:spcPct val="105000"/>
+              </a:lnSpc>
+              <a:spcAft>
+                <a:spcPts val="100"/>
+              </a:spcAft>
+            </a:pPr>
+            <a:r>
+              <a:rPr sz="1250" b="1" i="0">
                 <a:solidFill>
                   <a:srgbClr val="EAF0F8"/>
                 </a:solidFill>
@@ -4182,14 +4182,14 @@
           <a:p>
             <a:pPr algn="l">
               <a:lnSpc>
-                <a:spcPct val="107000"/>
-              </a:lnSpc>
-              <a:spcAft>
-                <a:spcPts val="200"/>
-              </a:spcAft>
-            </a:pPr>
-            <a:r>
-              <a:rPr sz="1160" b="0" i="0">
+                <a:spcPct val="105000"/>
+              </a:lnSpc>
+              <a:spcAft>
+                <a:spcPts val="100"/>
+              </a:spcAft>
+            </a:pPr>
+            <a:r>
+              <a:rPr sz="1080" b="0" i="0">
                 <a:solidFill>
                   <a:srgbClr val="93A0B6"/>
                 </a:solidFill>
@@ -4208,8 +4208,8 @@
         </p:nvSpPr>
         <p:spPr>
           <a:xfrm>
-            <a:off x="8001000" y="2889504"/>
-            <a:ext cx="146304" cy="146304"/>
+            <a:off x="8001000" y="2633472"/>
+            <a:ext cx="137160" cy="137160"/>
           </a:xfrm>
           <a:prstGeom prst="roundRect">
             <a:avLst>
@@ -4254,30 +4254,30 @@
         </p:nvSpPr>
         <p:spPr>
           <a:xfrm>
-            <a:off x="8293608" y="2852928"/>
-            <a:ext cx="3749039" cy="1097280"/>
-          </a:xfrm>
-          <a:prstGeom prst="rect">
-            <a:avLst/>
-          </a:prstGeom>
-          <a:noFill/>
-        </p:spPr>
-        <p:txBody>
-          <a:bodyPr wrap="square" anchor="t" lIns="0" rIns="0" tIns="0" bIns="0">
-            <a:spAutoFit/>
-          </a:bodyPr>
-          <a:lstStyle/>
-          <a:p>
-            <a:pPr algn="l">
-              <a:lnSpc>
-                <a:spcPct val="107000"/>
-              </a:lnSpc>
-              <a:spcAft>
-                <a:spcPts val="200"/>
-              </a:spcAft>
-            </a:pPr>
-            <a:r>
-              <a:rPr sz="1350" b="1" i="0">
+            <a:off x="8293608" y="2596896"/>
+            <a:ext cx="3749039" cy="1005840"/>
+          </a:xfrm>
+          <a:prstGeom prst="rect">
+            <a:avLst/>
+          </a:prstGeom>
+          <a:noFill/>
+        </p:spPr>
+        <p:txBody>
+          <a:bodyPr wrap="square" anchor="t" lIns="0" rIns="0" tIns="0" bIns="0">
+            <a:spAutoFit/>
+          </a:bodyPr>
+          <a:lstStyle/>
+          <a:p>
+            <a:pPr algn="l">
+              <a:lnSpc>
+                <a:spcPct val="105000"/>
+              </a:lnSpc>
+              <a:spcAft>
+                <a:spcPts val="100"/>
+              </a:spcAft>
+            </a:pPr>
+            <a:r>
+              <a:rPr sz="1250" b="1" i="0">
                 <a:solidFill>
                   <a:srgbClr val="EAF0F8"/>
                 </a:solidFill>
@@ -4289,14 +4289,14 @@
           <a:p>
             <a:pPr algn="l">
               <a:lnSpc>
-                <a:spcPct val="107000"/>
-              </a:lnSpc>
-              <a:spcAft>
-                <a:spcPts val="200"/>
-              </a:spcAft>
-            </a:pPr>
-            <a:r>
-              <a:rPr sz="1160" b="0" i="0">
+                <a:spcPct val="105000"/>
+              </a:lnSpc>
+              <a:spcAft>
+                <a:spcPts val="100"/>
+              </a:spcAft>
+            </a:pPr>
+            <a:r>
+              <a:rPr sz="1080" b="0" i="0">
                 <a:solidFill>
                   <a:srgbClr val="93A0B6"/>
                 </a:solidFill>
@@ -4315,8 +4315,115 @@
         </p:nvSpPr>
         <p:spPr>
           <a:xfrm>
-            <a:off x="8001000" y="4005072"/>
-            <a:ext cx="146304" cy="146304"/>
+            <a:off x="8001000" y="3602736"/>
+            <a:ext cx="137160" cy="137160"/>
+          </a:xfrm>
+          <a:prstGeom prst="roundRect">
+            <a:avLst>
+              <a:gd name="adj" fmla="val 18000"/>
+            </a:avLst>
+          </a:prstGeom>
+          <a:solidFill>
+            <a:srgbClr val="5FB6D9"/>
+          </a:solidFill>
+          <a:ln>
+            <a:noFill/>
+          </a:ln>
+          <a:effectLst/>
+        </p:spPr>
+        <p:style>
+          <a:lnRef idx="1">
+            <a:schemeClr val="accent1"/>
+          </a:lnRef>
+          <a:fillRef idx="3">
+            <a:schemeClr val="accent1"/>
+          </a:fillRef>
+          <a:effectRef idx="2">
+            <a:schemeClr val="accent1"/>
+          </a:effectRef>
+          <a:fontRef idx="minor">
+            <a:schemeClr val="lt1"/>
+          </a:fontRef>
+        </p:style>
+        <p:txBody>
+          <a:bodyPr rtlCol="0" anchor="ctr"/>
+          <a:lstStyle/>
+          <a:p>
+            <a:pPr algn="ctr"/>
+          </a:p>
+        </p:txBody>
+      </p:sp>
+      <p:sp>
+        <p:nvSpPr>
+          <p:cNvPr id="10" name="TextBox 9"/>
+          <p:cNvSpPr txBox="1"/>
+          <p:nvPr/>
+        </p:nvSpPr>
+        <p:spPr>
+          <a:xfrm>
+            <a:off x="8293608" y="3566160"/>
+            <a:ext cx="3749039" cy="1005840"/>
+          </a:xfrm>
+          <a:prstGeom prst="rect">
+            <a:avLst/>
+          </a:prstGeom>
+          <a:noFill/>
+        </p:spPr>
+        <p:txBody>
+          <a:bodyPr wrap="square" anchor="t" lIns="0" rIns="0" tIns="0" bIns="0">
+            <a:spAutoFit/>
+          </a:bodyPr>
+          <a:lstStyle/>
+          <a:p>
+            <a:pPr algn="l">
+              <a:lnSpc>
+                <a:spcPct val="105000"/>
+              </a:lnSpc>
+              <a:spcAft>
+                <a:spcPts val="100"/>
+              </a:spcAft>
+            </a:pPr>
+            <a:r>
+              <a:rPr sz="1250" b="1" i="0">
+                <a:solidFill>
+                  <a:srgbClr val="EAF0F8"/>
+                </a:solidFill>
+                <a:latin typeface="Arial"/>
+              </a:rPr>
+              <a:t>The regulars are hot too</a:t>
+            </a:r>
+          </a:p>
+          <a:p>
+            <a:pPr algn="l">
+              <a:lnSpc>
+                <a:spcPct val="105000"/>
+              </a:lnSpc>
+              <a:spcAft>
+                <a:spcPts val="100"/>
+              </a:spcAft>
+            </a:pPr>
+            <a:r>
+              <a:rPr sz="1080" b="0" i="0">
+                <a:solidFill>
+                  <a:srgbClr val="93A0B6"/>
+                </a:solidFill>
+                <a:latin typeface="Arial"/>
+              </a:rPr>
+              <a:t>Same screen on the everyday lineup: Contreras +130 OPS pts, Rafaela +76 OPS pts. Expect good, not scorching, from here.</a:t>
+            </a:r>
+          </a:p>
+        </p:txBody>
+      </p:sp>
+      <p:sp>
+        <p:nvSpPr>
+          <p:cNvPr id="11" name="Rounded Rectangle 10"/>
+          <p:cNvSpPr/>
+          <p:nvPr/>
+        </p:nvSpPr>
+        <p:spPr>
+          <a:xfrm>
+            <a:off x="8001000" y="4572000"/>
+            <a:ext cx="137160" cy="137160"/>
           </a:xfrm>
           <a:prstGeom prst="roundRect">
             <a:avLst>
@@ -4355,36 +4462,36 @@
       </p:sp>
       <p:sp>
         <p:nvSpPr>
-          <p:cNvPr id="10" name="TextBox 9"/>
-          <p:cNvSpPr txBox="1"/>
-          <p:nvPr/>
-        </p:nvSpPr>
-        <p:spPr>
-          <a:xfrm>
-            <a:off x="8293608" y="3968496"/>
-            <a:ext cx="3749039" cy="1097280"/>
-          </a:xfrm>
-          <a:prstGeom prst="rect">
-            <a:avLst/>
-          </a:prstGeom>
-          <a:noFill/>
-        </p:spPr>
-        <p:txBody>
-          <a:bodyPr wrap="square" anchor="t" lIns="0" rIns="0" tIns="0" bIns="0">
-            <a:spAutoFit/>
-          </a:bodyPr>
-          <a:lstStyle/>
-          <a:p>
-            <a:pPr algn="l">
-              <a:lnSpc>
-                <a:spcPct val="107000"/>
-              </a:lnSpc>
-              <a:spcAft>
-                <a:spcPts val="200"/>
-              </a:spcAft>
-            </a:pPr>
-            <a:r>
-              <a:rPr sz="1350" b="1" i="0">
+          <p:cNvPr id="12" name="TextBox 11"/>
+          <p:cNvSpPr txBox="1"/>
+          <p:nvPr/>
+        </p:nvSpPr>
+        <p:spPr>
+          <a:xfrm>
+            <a:off x="8293608" y="4535424"/>
+            <a:ext cx="3749039" cy="1005840"/>
+          </a:xfrm>
+          <a:prstGeom prst="rect">
+            <a:avLst/>
+          </a:prstGeom>
+          <a:noFill/>
+        </p:spPr>
+        <p:txBody>
+          <a:bodyPr wrap="square" anchor="t" lIns="0" rIns="0" tIns="0" bIns="0">
+            <a:spAutoFit/>
+          </a:bodyPr>
+          <a:lstStyle/>
+          <a:p>
+            <a:pPr algn="l">
+              <a:lnSpc>
+                <a:spcPct val="105000"/>
+              </a:lnSpc>
+              <a:spcAft>
+                <a:spcPts val="100"/>
+              </a:spcAft>
+            </a:pPr>
+            <a:r>
+              <a:rPr sz="1250" b="1" i="0">
                 <a:solidFill>
                   <a:srgbClr val="EAF0F8"/>
                 </a:solidFill>
@@ -4396,34 +4503,34 @@
           <a:p>
             <a:pPr algn="l">
               <a:lnSpc>
-                <a:spcPct val="107000"/>
-              </a:lnSpc>
-              <a:spcAft>
-                <a:spcPts val="200"/>
-              </a:spcAft>
-            </a:pPr>
-            <a:r>
-              <a:rPr sz="1160" b="0" i="0">
+                <a:spcPct val="105000"/>
+              </a:lnSpc>
+              <a:spcAft>
+                <a:spcPts val="100"/>
+              </a:spcAft>
+            </a:pPr>
+            <a:r>
+              <a:rPr sz="1080" b="0" i="0">
                 <a:solidFill>
                   <a:srgbClr val="93A0B6"/>
                 </a:solidFill>
                 <a:latin typeface="Arial"/>
               </a:rPr>
-              <a:t>2016-25, 100 hitter and 198 reliever cases like these: the median journeyman kept only 39% of a career-best first half (fig. 20).</a:t>
-            </a:r>
-          </a:p>
-        </p:txBody>
-      </p:sp>
-      <p:sp>
-        <p:nvSpPr>
-          <p:cNvPr id="11" name="Rounded Rectangle 10"/>
+              <a:t>2016-25, 100 hitter and 198 reliever cases: the median journeyman kept only 39% of a career-best first half (fig. 20).</a:t>
+            </a:r>
+          </a:p>
+        </p:txBody>
+      </p:sp>
+      <p:sp>
+        <p:nvSpPr>
+          <p:cNvPr id="13" name="Rounded Rectangle 12"/>
           <p:cNvSpPr/>
           <p:nvPr/>
         </p:nvSpPr>
         <p:spPr>
           <a:xfrm>
-            <a:off x="8001000" y="5120640"/>
-            <a:ext cx="146304" cy="146304"/>
+            <a:off x="8001000" y="5541264"/>
+            <a:ext cx="137160" cy="137160"/>
           </a:xfrm>
           <a:prstGeom prst="roundRect">
             <a:avLst>
@@ -4462,36 +4569,36 @@
       </p:sp>
       <p:sp>
         <p:nvSpPr>
-          <p:cNvPr id="12" name="TextBox 11"/>
-          <p:cNvSpPr txBox="1"/>
-          <p:nvPr/>
-        </p:nvSpPr>
-        <p:spPr>
-          <a:xfrm>
-            <a:off x="8293608" y="5084064"/>
-            <a:ext cx="3749039" cy="1097280"/>
-          </a:xfrm>
-          <a:prstGeom prst="rect">
-            <a:avLst/>
-          </a:prstGeom>
-          <a:noFill/>
-        </p:spPr>
-        <p:txBody>
-          <a:bodyPr wrap="square" anchor="t" lIns="0" rIns="0" tIns="0" bIns="0">
-            <a:spAutoFit/>
-          </a:bodyPr>
-          <a:lstStyle/>
-          <a:p>
-            <a:pPr algn="l">
-              <a:lnSpc>
-                <a:spcPct val="107000"/>
-              </a:lnSpc>
-              <a:spcAft>
-                <a:spcPts val="200"/>
-              </a:spcAft>
-            </a:pPr>
-            <a:r>
-              <a:rPr sz="1350" b="1" i="0">
+          <p:cNvPr id="14" name="TextBox 13"/>
+          <p:cNvSpPr txBox="1"/>
+          <p:nvPr/>
+        </p:nvSpPr>
+        <p:spPr>
+          <a:xfrm>
+            <a:off x="8293608" y="5504688"/>
+            <a:ext cx="3749039" cy="1005840"/>
+          </a:xfrm>
+          <a:prstGeom prst="rect">
+            <a:avLst/>
+          </a:prstGeom>
+          <a:noFill/>
+        </p:spPr>
+        <p:txBody>
+          <a:bodyPr wrap="square" anchor="t" lIns="0" rIns="0" tIns="0" bIns="0">
+            <a:spAutoFit/>
+          </a:bodyPr>
+          <a:lstStyle/>
+          <a:p>
+            <a:pPr algn="l">
+              <a:lnSpc>
+                <a:spcPct val="105000"/>
+              </a:lnSpc>
+              <a:spcAft>
+                <a:spcPts val="100"/>
+              </a:spcAft>
+            </a:pPr>
+            <a:r>
+              <a:rPr sz="1250" b="1" i="0">
                 <a:solidFill>
                   <a:srgbClr val="EAF0F8"/>
                 </a:solidFill>
@@ -4503,14 +4610,14 @@
           <a:p>
             <a:pPr algn="l">
               <a:lnSpc>
-                <a:spcPct val="107000"/>
-              </a:lnSpc>
-              <a:spcAft>
-                <a:spcPts val="200"/>
-              </a:spcAft>
-            </a:pPr>
-            <a:r>
-              <a:rPr sz="1160" b="0" i="0">
+                <a:spcPct val="105000"/>
+              </a:lnSpc>
+              <a:spcAft>
+                <a:spcPts val="100"/>
+              </a:spcAft>
+            </a:pPr>
+            <a:r>
+              <a:rPr sz="1080" b="0" i="0">
                 <a:solidFill>
                   <a:srgbClr val="93A0B6"/>
                 </a:solidFill>
@@ -4523,7 +4630,7 @@
       </p:sp>
       <p:sp>
         <p:nvSpPr>
-          <p:cNvPr id="13" name="TextBox 12"/>
+          <p:cNvPr id="15" name="TextBox 14"/>
           <p:cNvSpPr txBox="1"/>
           <p:nvPr/>
         </p:nvSpPr>

</xml_diff>

<commit_message>
Trade-comparison slide; end slides cut per the user's edit
- Removed the two closing strategy slides (winter what-to-get and the
  buy-now/decide-winter plan), keeping BOTTOM LINE; deck at 17 slides
- New slide after the Mead acquisition: 'Why Mead for Early wins for
  Boston'. Left card: Early's 3.44 ERA was carrying a 4.61 FIP, the
  largest gap on the staff, and his 6'3"/195 frame is the smallest in
  the rookie pipeline. Right card: Mead's earned 134 wRC+ with control
  and the pull-air park fit. Factory band: Tolle (6'6", 250, 3.31/3.24)
  and Bennett (6'6", 234, 2.58/3.12) are bigger and better by FIP
- All numbers pulled live (FanGraphs + StatsAPI bios) into
  acquisition.json; article's trade section gains the Early-side
  paragraph making the same case

Co-Authored-By: Claude Fable 5 <noreply@anthropic.com>
</commit_message>
<xml_diff>
--- a/outputs/Red_Sox_Trade_Deadline.pptx
+++ b/outputs/Red_Sox_Trade_Deadline.pptx
@@ -22,7 +22,6 @@
     <p:sldId id="270" r:id="rId21"/>
     <p:sldId id="271" r:id="rId22"/>
     <p:sldId id="272" r:id="rId23"/>
-    <p:sldId id="273" r:id="rId24"/>
   </p:sldIdLst>
   <p:sldSz cx="12191695" cy="6858000" type="screen4x3"/>
   <p:notesSz cx="6858000" cy="9144000"/>
@@ -7382,7 +7381,7 @@
                 </a:solidFill>
                 <a:latin typeface="Courier New"/>
               </a:rPr>
-              <a:t>// THE WINTER PLAN</a:t>
+              <a:t>// THE TRADE, GRADED</a:t>
             </a:r>
           </a:p>
         </p:txBody>
@@ -7424,63 +7423,21 @@
                 </a:solidFill>
                 <a:latin typeface="Arial"/>
               </a:rPr>
-              <a:t>Spend the pitching surplus on offense</a:t>
-            </a:r>
-          </a:p>
-        </p:txBody>
-      </p:sp>
-      <p:sp>
-        <p:nvSpPr>
-          <p:cNvPr id="4" name="TextBox 3"/>
-          <p:cNvSpPr txBox="1"/>
-          <p:nvPr/>
-        </p:nvSpPr>
-        <p:spPr>
-          <a:xfrm>
-            <a:off x="566928" y="1572768"/>
-            <a:ext cx="11064240" cy="640080"/>
-          </a:xfrm>
-          <a:prstGeom prst="rect">
-            <a:avLst/>
-          </a:prstGeom>
-          <a:noFill/>
-        </p:spPr>
-        <p:txBody>
-          <a:bodyPr wrap="square" anchor="t" lIns="0" rIns="0" tIns="0" bIns="0">
-            <a:spAutoFit/>
-          </a:bodyPr>
-          <a:lstStyle/>
-          <a:p>
-            <a:pPr algn="l">
-              <a:lnSpc>
-                <a:spcPct val="112000"/>
-              </a:lnSpc>
-              <a:spcAft>
-                <a:spcPts val="400"/>
-              </a:spcAft>
-            </a:pPr>
-            <a:r>
-              <a:rPr sz="1450" b="0" i="0">
-                <a:solidFill>
-                  <a:srgbClr val="D9E1EF"/>
-                </a:solidFill>
-                <a:latin typeface="Arial"/>
-              </a:rPr>
-              <a:t>If winter comes and Duran's rebound has shown up, this is what a deal should return. With a top-6 rotation (3.65 ERA) carrying the club, trading bats for arms is backwards, convert the outfield surplus into what's thin:</a:t>
-            </a:r>
-          </a:p>
-        </p:txBody>
-      </p:sp>
-      <p:sp>
-        <p:nvSpPr>
-          <p:cNvPr id="5" name="Rounded Rectangle 4"/>
+              <a:t>Why Mead for Early wins for Boston</a:t>
+            </a:r>
+          </a:p>
+        </p:txBody>
+      </p:sp>
+      <p:sp>
+        <p:nvSpPr>
+          <p:cNvPr id="4" name="Rounded Rectangle 3"/>
           <p:cNvSpPr/>
           <p:nvPr/>
         </p:nvSpPr>
         <p:spPr>
           <a:xfrm>
-            <a:off x="566928" y="2468880"/>
-            <a:ext cx="3502152" cy="2514600"/>
+            <a:off x="566928" y="1691640"/>
+            <a:ext cx="5358384" cy="3291840"/>
           </a:xfrm>
           <a:prstGeom prst="roundRect">
             <a:avLst>
@@ -7521,14 +7478,56 @@
       </p:sp>
       <p:sp>
         <p:nvSpPr>
+          <p:cNvPr id="5" name="TextBox 4"/>
+          <p:cNvSpPr txBox="1"/>
+          <p:nvPr/>
+        </p:nvSpPr>
+        <p:spPr>
+          <a:xfrm>
+            <a:off x="859536" y="1920240"/>
+            <a:ext cx="4809744" cy="457200"/>
+          </a:xfrm>
+          <a:prstGeom prst="rect">
+            <a:avLst/>
+          </a:prstGeom>
+          <a:noFill/>
+        </p:spPr>
+        <p:txBody>
+          <a:bodyPr wrap="square" anchor="t" lIns="0" rIns="0" tIns="0" bIns="0">
+            <a:spAutoFit/>
+          </a:bodyPr>
+          <a:lstStyle/>
+          <a:p>
+            <a:pPr algn="l">
+              <a:lnSpc>
+                <a:spcPct val="100000"/>
+              </a:lnSpc>
+              <a:spcAft>
+                <a:spcPts val="0"/>
+              </a:spcAft>
+            </a:pPr>
+            <a:r>
+              <a:rPr sz="1700" b="1" i="0">
+                <a:solidFill>
+                  <a:srgbClr val="EAF0F8"/>
+                </a:solidFill>
+                <a:latin typeface="Arial"/>
+              </a:rPr>
+              <a:t>What they gave: Connelly Early</a:t>
+            </a:r>
+          </a:p>
+        </p:txBody>
+      </p:sp>
+      <p:sp>
+        <p:nvSpPr>
           <p:cNvPr id="6" name="Rounded Rectangle 5"/>
           <p:cNvSpPr/>
           <p:nvPr/>
         </p:nvSpPr>
         <p:spPr>
           <a:xfrm>
-            <a:off x="841247" y="2724912"/>
-            <a:ext cx="384048" cy="384048"/>
+            <a:off x="859536" y="2560320"/>
+            <a:ext cx="118872" cy="118872"/>
           </a:xfrm>
           <a:prstGeom prst="roundRect">
             <a:avLst>
@@ -7536,7 +7535,7 @@
             </a:avLst>
           </a:prstGeom>
           <a:solidFill>
-            <a:srgbClr val="58C08D"/>
+            <a:srgbClr val="E8615A"/>
           </a:solidFill>
           <a:ln>
             <a:noFill/>
@@ -7558,19 +7557,10 @@
           </a:fontRef>
         </p:style>
         <p:txBody>
-          <a:bodyPr rtlCol="0" anchor="ctr" wrap="none"/>
+          <a:bodyPr rtlCol="0" anchor="ctr"/>
           <a:lstStyle/>
           <a:p>
             <a:pPr algn="ctr"/>
-            <a:r>
-              <a:rPr sz="1600" b="1">
-                <a:solidFill>
-                  <a:srgbClr val="0B1220"/>
-                </a:solidFill>
-                <a:latin typeface="Courier New"/>
-              </a:rPr>
-              <a:t>1</a:t>
-            </a:r>
           </a:p>
         </p:txBody>
       </p:sp>
@@ -7582,92 +7572,156 @@
         </p:nvSpPr>
         <p:spPr>
           <a:xfrm>
-            <a:off x="841247" y="3310128"/>
-            <a:ext cx="2999232" cy="411480"/>
-          </a:xfrm>
-          <a:prstGeom prst="rect">
-            <a:avLst/>
-          </a:prstGeom>
-          <a:noFill/>
-        </p:spPr>
-        <p:txBody>
-          <a:bodyPr wrap="square" anchor="t" lIns="0" rIns="0" tIns="0" bIns="0">
-            <a:spAutoFit/>
-          </a:bodyPr>
-          <a:lstStyle/>
-          <a:p>
-            <a:pPr algn="l">
-              <a:lnSpc>
-                <a:spcPct val="100000"/>
-              </a:lnSpc>
-              <a:spcAft>
-                <a:spcPts val="0"/>
-              </a:spcAft>
-            </a:pPr>
-            <a:r>
-              <a:rPr sz="1600" b="1" i="0">
-                <a:solidFill>
-                  <a:srgbClr val="EAF0F8"/>
-                </a:solidFill>
-                <a:latin typeface="Arial"/>
-              </a:rPr>
-              <a:t>Controllable bats</a:t>
-            </a:r>
-          </a:p>
-        </p:txBody>
-      </p:sp>
-      <p:sp>
-        <p:nvSpPr>
-          <p:cNvPr id="8" name="TextBox 7"/>
-          <p:cNvSpPr txBox="1"/>
-          <p:nvPr/>
-        </p:nvSpPr>
-        <p:spPr>
-          <a:xfrm>
-            <a:off x="841247" y="3767328"/>
-            <a:ext cx="2999232" cy="1097280"/>
-          </a:xfrm>
-          <a:prstGeom prst="rect">
-            <a:avLst/>
-          </a:prstGeom>
-          <a:noFill/>
-        </p:spPr>
-        <p:txBody>
-          <a:bodyPr wrap="square" anchor="t" lIns="0" rIns="0" tIns="0" bIns="0">
-            <a:spAutoFit/>
-          </a:bodyPr>
-          <a:lstStyle/>
-          <a:p>
-            <a:pPr algn="l">
-              <a:lnSpc>
-                <a:spcPct val="110000"/>
+            <a:off x="1097280" y="2514600"/>
+            <a:ext cx="4489704" cy="1188720"/>
+          </a:xfrm>
+          <a:prstGeom prst="rect">
+            <a:avLst/>
+          </a:prstGeom>
+          <a:noFill/>
+        </p:spPr>
+        <p:txBody>
+          <a:bodyPr wrap="square" anchor="t" lIns="0" rIns="0" tIns="0" bIns="0">
+            <a:spAutoFit/>
+          </a:bodyPr>
+          <a:lstStyle/>
+          <a:p>
+            <a:pPr algn="l">
+              <a:lnSpc>
+                <a:spcPct val="109000"/>
               </a:lnSpc>
               <a:spcAft>
                 <a:spcPts val="400"/>
               </a:spcAft>
             </a:pPr>
             <a:r>
-              <a:rPr sz="1280" b="0" i="0">
+              <a:rPr sz="1300" b="1" i="0">
+                <a:solidFill>
+                  <a:srgbClr val="D9E1EF"/>
+                </a:solidFill>
+                <a:latin typeface="Arial"/>
+              </a:rPr>
+              <a:t>The ERA flattered him. </a:t>
+            </a:r>
+            <a:r>
+              <a:rPr sz="1220" b="0" i="0">
                 <a:solidFill>
                   <a:srgbClr val="93A0B6"/>
                 </a:solidFill>
                 <a:latin typeface="Arial"/>
               </a:rPr>
-              <a:t>Young, cost-controlled position players to fix an inconsistent lineup and lengthen it around the core.</a:t>
-            </a:r>
-          </a:p>
-        </p:txBody>
-      </p:sp>
-      <p:sp>
-        <p:nvSpPr>
-          <p:cNvPr id="9" name="Rounded Rectangle 8"/>
+              <a:t>3.44 ERA over a 4.61 FIP, a +1.17 gap, the most of any Boston starter. Sold at peak perception.</a:t>
+            </a:r>
+          </a:p>
+        </p:txBody>
+      </p:sp>
+      <p:sp>
+        <p:nvSpPr>
+          <p:cNvPr id="8" name="Rounded Rectangle 7"/>
           <p:cNvSpPr/>
           <p:nvPr/>
         </p:nvSpPr>
         <p:spPr>
           <a:xfrm>
-            <a:off x="4352544" y="2468880"/>
-            <a:ext cx="3502152" cy="2514600"/>
+            <a:off x="859536" y="3749039"/>
+            <a:ext cx="118872" cy="118872"/>
+          </a:xfrm>
+          <a:prstGeom prst="roundRect">
+            <a:avLst>
+              <a:gd name="adj" fmla="val 18000"/>
+            </a:avLst>
+          </a:prstGeom>
+          <a:solidFill>
+            <a:srgbClr val="E8615A"/>
+          </a:solidFill>
+          <a:ln>
+            <a:noFill/>
+          </a:ln>
+          <a:effectLst/>
+        </p:spPr>
+        <p:style>
+          <a:lnRef idx="1">
+            <a:schemeClr val="accent1"/>
+          </a:lnRef>
+          <a:fillRef idx="3">
+            <a:schemeClr val="accent1"/>
+          </a:fillRef>
+          <a:effectRef idx="2">
+            <a:schemeClr val="accent1"/>
+          </a:effectRef>
+          <a:fontRef idx="minor">
+            <a:schemeClr val="lt1"/>
+          </a:fontRef>
+        </p:style>
+        <p:txBody>
+          <a:bodyPr rtlCol="0" anchor="ctr"/>
+          <a:lstStyle/>
+          <a:p>
+            <a:pPr algn="ctr"/>
+          </a:p>
+        </p:txBody>
+      </p:sp>
+      <p:sp>
+        <p:nvSpPr>
+          <p:cNvPr id="9" name="TextBox 8"/>
+          <p:cNvSpPr txBox="1"/>
+          <p:nvPr/>
+        </p:nvSpPr>
+        <p:spPr>
+          <a:xfrm>
+            <a:off x="1097280" y="3703320"/>
+            <a:ext cx="4489704" cy="1188720"/>
+          </a:xfrm>
+          <a:prstGeom prst="rect">
+            <a:avLst/>
+          </a:prstGeom>
+          <a:noFill/>
+        </p:spPr>
+        <p:txBody>
+          <a:bodyPr wrap="square" anchor="t" lIns="0" rIns="0" tIns="0" bIns="0">
+            <a:spAutoFit/>
+          </a:bodyPr>
+          <a:lstStyle/>
+          <a:p>
+            <a:pPr algn="l">
+              <a:lnSpc>
+                <a:spcPct val="109000"/>
+              </a:lnSpc>
+              <a:spcAft>
+                <a:spcPts val="400"/>
+              </a:spcAft>
+            </a:pPr>
+            <a:r>
+              <a:rPr sz="1300" b="1" i="0">
+                <a:solidFill>
+                  <a:srgbClr val="D9E1EF"/>
+                </a:solidFill>
+                <a:latin typeface="Arial"/>
+              </a:rPr>
+              <a:t>The smallest frame in the pipeline. </a:t>
+            </a:r>
+            <a:r>
+              <a:rPr sz="1220" b="0" i="0">
+                <a:solidFill>
+                  <a:srgbClr val="93A0B6"/>
+                </a:solidFill>
+                <a:latin typeface="Arial"/>
+              </a:rPr>
+              <a:t>6' 3", 195 lbs. Durability risk the org's other arms don't carry.</a:t>
+            </a:r>
+          </a:p>
+        </p:txBody>
+      </p:sp>
+      <p:sp>
+        <p:nvSpPr>
+          <p:cNvPr id="10" name="Rounded Rectangle 9"/>
+          <p:cNvSpPr/>
+          <p:nvPr/>
+        </p:nvSpPr>
+        <p:spPr>
+          <a:xfrm>
+            <a:off x="6227064" y="1691640"/>
+            <a:ext cx="5358384" cy="3291840"/>
           </a:xfrm>
           <a:prstGeom prst="roundRect">
             <a:avLst>
@@ -7708,14 +7762,56 @@
       </p:sp>
       <p:sp>
         <p:nvSpPr>
-          <p:cNvPr id="10" name="Rounded Rectangle 9"/>
+          <p:cNvPr id="11" name="TextBox 10"/>
+          <p:cNvSpPr txBox="1"/>
+          <p:nvPr/>
+        </p:nvSpPr>
+        <p:spPr>
+          <a:xfrm>
+            <a:off x="6519672" y="1920240"/>
+            <a:ext cx="4809744" cy="457200"/>
+          </a:xfrm>
+          <a:prstGeom prst="rect">
+            <a:avLst/>
+          </a:prstGeom>
+          <a:noFill/>
+        </p:spPr>
+        <p:txBody>
+          <a:bodyPr wrap="square" anchor="t" lIns="0" rIns="0" tIns="0" bIns="0">
+            <a:spAutoFit/>
+          </a:bodyPr>
+          <a:lstStyle/>
+          <a:p>
+            <a:pPr algn="l">
+              <a:lnSpc>
+                <a:spcPct val="100000"/>
+              </a:lnSpc>
+              <a:spcAft>
+                <a:spcPts val="0"/>
+              </a:spcAft>
+            </a:pPr>
+            <a:r>
+              <a:rPr sz="1700" b="1" i="0">
+                <a:solidFill>
+                  <a:srgbClr val="EAF0F8"/>
+                </a:solidFill>
+                <a:latin typeface="Arial"/>
+              </a:rPr>
+              <a:t>What they got: Curtis Mead</a:t>
+            </a:r>
+          </a:p>
+        </p:txBody>
+      </p:sp>
+      <p:sp>
+        <p:nvSpPr>
+          <p:cNvPr id="12" name="Rounded Rectangle 11"/>
           <p:cNvSpPr/>
           <p:nvPr/>
         </p:nvSpPr>
         <p:spPr>
           <a:xfrm>
-            <a:off x="4626864" y="2724912"/>
-            <a:ext cx="384048" cy="384048"/>
+            <a:off x="6519672" y="2560320"/>
+            <a:ext cx="118872" cy="118872"/>
           </a:xfrm>
           <a:prstGeom prst="roundRect">
             <a:avLst>
@@ -7723,7 +7819,7 @@
             </a:avLst>
           </a:prstGeom>
           <a:solidFill>
-            <a:srgbClr val="EAF0F8"/>
+            <a:srgbClr val="58C08D"/>
           </a:solidFill>
           <a:ln>
             <a:noFill/>
@@ -7745,129 +7841,85 @@
           </a:fontRef>
         </p:style>
         <p:txBody>
-          <a:bodyPr rtlCol="0" anchor="ctr" wrap="none"/>
+          <a:bodyPr rtlCol="0" anchor="ctr"/>
           <a:lstStyle/>
           <a:p>
             <a:pPr algn="ctr"/>
-            <a:r>
-              <a:rPr sz="1600" b="1">
-                <a:solidFill>
-                  <a:srgbClr val="0B1220"/>
-                </a:solidFill>
-                <a:latin typeface="Courier New"/>
-              </a:rPr>
-              <a:t>2</a:t>
-            </a:r>
-          </a:p>
-        </p:txBody>
-      </p:sp>
-      <p:sp>
-        <p:nvSpPr>
-          <p:cNvPr id="11" name="TextBox 10"/>
-          <p:cNvSpPr txBox="1"/>
-          <p:nvPr/>
-        </p:nvSpPr>
-        <p:spPr>
-          <a:xfrm>
-            <a:off x="4626864" y="3310128"/>
-            <a:ext cx="2999232" cy="411480"/>
-          </a:xfrm>
-          <a:prstGeom prst="rect">
-            <a:avLst/>
-          </a:prstGeom>
-          <a:noFill/>
-        </p:spPr>
-        <p:txBody>
-          <a:bodyPr wrap="square" anchor="t" lIns="0" rIns="0" tIns="0" bIns="0">
-            <a:spAutoFit/>
-          </a:bodyPr>
-          <a:lstStyle/>
-          <a:p>
-            <a:pPr algn="l">
-              <a:lnSpc>
-                <a:spcPct val="100000"/>
-              </a:lnSpc>
-              <a:spcAft>
-                <a:spcPts val="0"/>
-              </a:spcAft>
-            </a:pPr>
-            <a:r>
-              <a:rPr sz="1600" b="1" i="0">
-                <a:solidFill>
-                  <a:srgbClr val="EAF0F8"/>
-                </a:solidFill>
-                <a:latin typeface="Arial"/>
-              </a:rPr>
-              <a:t>Best talent / upside</a:t>
-            </a:r>
-          </a:p>
-        </p:txBody>
-      </p:sp>
-      <p:sp>
-        <p:nvSpPr>
-          <p:cNvPr id="12" name="TextBox 11"/>
-          <p:cNvSpPr txBox="1"/>
-          <p:nvPr/>
-        </p:nvSpPr>
-        <p:spPr>
-          <a:xfrm>
-            <a:off x="4626864" y="3767328"/>
-            <a:ext cx="2999232" cy="1097280"/>
-          </a:xfrm>
-          <a:prstGeom prst="rect">
-            <a:avLst/>
-          </a:prstGeom>
-          <a:noFill/>
-        </p:spPr>
-        <p:txBody>
-          <a:bodyPr wrap="square" anchor="t" lIns="0" rIns="0" tIns="0" bIns="0">
-            <a:spAutoFit/>
-          </a:bodyPr>
-          <a:lstStyle/>
-          <a:p>
-            <a:pPr algn="l">
-              <a:lnSpc>
-                <a:spcPct val="110000"/>
+          </a:p>
+        </p:txBody>
+      </p:sp>
+      <p:sp>
+        <p:nvSpPr>
+          <p:cNvPr id="13" name="TextBox 12"/>
+          <p:cNvSpPr txBox="1"/>
+          <p:nvPr/>
+        </p:nvSpPr>
+        <p:spPr>
+          <a:xfrm>
+            <a:off x="6757416" y="2514600"/>
+            <a:ext cx="4489704" cy="1188720"/>
+          </a:xfrm>
+          <a:prstGeom prst="rect">
+            <a:avLst/>
+          </a:prstGeom>
+          <a:noFill/>
+        </p:spPr>
+        <p:txBody>
+          <a:bodyPr wrap="square" anchor="t" lIns="0" rIns="0" tIns="0" bIns="0">
+            <a:spAutoFit/>
+          </a:bodyPr>
+          <a:lstStyle/>
+          <a:p>
+            <a:pPr algn="l">
+              <a:lnSpc>
+                <a:spcPct val="109000"/>
               </a:lnSpc>
               <a:spcAft>
                 <a:spcPts val="400"/>
               </a:spcAft>
             </a:pPr>
             <a:r>
-              <a:rPr sz="1280" b="0" i="0">
+              <a:rPr sz="1300" b="1" i="0">
+                <a:solidFill>
+                  <a:srgbClr val="D9E1EF"/>
+                </a:solidFill>
+                <a:latin typeface="Arial"/>
+              </a:rPr>
+              <a:t>A controllable, earned bat. </a:t>
+            </a:r>
+            <a:r>
+              <a:rPr sz="1220" b="0" i="0">
                 <a:solidFill>
                   <a:srgbClr val="93A0B6"/>
                 </a:solidFill>
                 <a:latin typeface="Arial"/>
               </a:rPr>
-              <a:t>In a retool you take the best player, not the positional patch, prospects and MLB-ready youth over rentals.</a:t>
-            </a:r>
-          </a:p>
-        </p:txBody>
-      </p:sp>
-      <p:sp>
-        <p:nvSpPr>
-          <p:cNvPr id="13" name="Rounded Rectangle 12"/>
+              <a:t>134 wRC+ at 25, backed by a .359 xwOBA. Years of club control at the position the audit flagged.</a:t>
+            </a:r>
+          </a:p>
+        </p:txBody>
+      </p:sp>
+      <p:sp>
+        <p:nvSpPr>
+          <p:cNvPr id="14" name="Rounded Rectangle 13"/>
           <p:cNvSpPr/>
           <p:nvPr/>
         </p:nvSpPr>
         <p:spPr>
           <a:xfrm>
-            <a:off x="8138159" y="2468880"/>
-            <a:ext cx="3502152" cy="2514600"/>
+            <a:off x="6519672" y="3749039"/>
+            <a:ext cx="118872" cy="118872"/>
           </a:xfrm>
           <a:prstGeom prst="roundRect">
             <a:avLst>
-              <a:gd name="adj" fmla="val 6000"/>
+              <a:gd name="adj" fmla="val 18000"/>
             </a:avLst>
           </a:prstGeom>
           <a:solidFill>
-            <a:srgbClr val="121E33"/>
+            <a:srgbClr val="58C08D"/>
           </a:solidFill>
-          <a:ln w="12700">
-            <a:solidFill>
-              <a:srgbClr val="26334E"/>
-            </a:solidFill>
+          <a:ln>
+            <a:noFill/>
           </a:ln>
           <a:effectLst/>
         </p:spPr>
@@ -7895,97 +7947,51 @@
       </p:sp>
       <p:sp>
         <p:nvSpPr>
-          <p:cNvPr id="14" name="Rounded Rectangle 13"/>
-          <p:cNvSpPr/>
-          <p:nvPr/>
-        </p:nvSpPr>
-        <p:spPr>
-          <a:xfrm>
-            <a:off x="8412480" y="2724912"/>
-            <a:ext cx="384048" cy="384048"/>
-          </a:xfrm>
-          <a:prstGeom prst="roundRect">
-            <a:avLst>
-              <a:gd name="adj" fmla="val 18000"/>
-            </a:avLst>
-          </a:prstGeom>
-          <a:solidFill>
-            <a:srgbClr val="E3B14E"/>
-          </a:solidFill>
-          <a:ln>
-            <a:noFill/>
-          </a:ln>
-          <a:effectLst/>
-        </p:spPr>
-        <p:style>
-          <a:lnRef idx="1">
-            <a:schemeClr val="accent1"/>
-          </a:lnRef>
-          <a:fillRef idx="3">
-            <a:schemeClr val="accent1"/>
-          </a:fillRef>
-          <a:effectRef idx="2">
-            <a:schemeClr val="accent1"/>
-          </a:effectRef>
-          <a:fontRef idx="minor">
-            <a:schemeClr val="lt1"/>
-          </a:fontRef>
-        </p:style>
-        <p:txBody>
-          <a:bodyPr rtlCol="0" anchor="ctr" wrap="none"/>
-          <a:lstStyle/>
-          <a:p>
-            <a:pPr algn="ctr"/>
-            <a:r>
-              <a:rPr sz="1600" b="1">
-                <a:solidFill>
-                  <a:srgbClr val="0B1220"/>
-                </a:solidFill>
-                <a:latin typeface="Courier New"/>
-              </a:rPr>
-              <a:t>3</a:t>
-            </a:r>
-          </a:p>
-        </p:txBody>
-      </p:sp>
-      <p:sp>
-        <p:nvSpPr>
           <p:cNvPr id="15" name="TextBox 14"/>
           <p:cNvSpPr txBox="1"/>
           <p:nvPr/>
         </p:nvSpPr>
         <p:spPr>
           <a:xfrm>
-            <a:off x="8412480" y="3310128"/>
-            <a:ext cx="2999232" cy="411480"/>
-          </a:xfrm>
-          <a:prstGeom prst="rect">
-            <a:avLst/>
-          </a:prstGeom>
-          <a:noFill/>
-        </p:spPr>
-        <p:txBody>
-          <a:bodyPr wrap="square" anchor="t" lIns="0" rIns="0" tIns="0" bIns="0">
-            <a:spAutoFit/>
-          </a:bodyPr>
-          <a:lstStyle/>
-          <a:p>
-            <a:pPr algn="l">
-              <a:lnSpc>
-                <a:spcPct val="100000"/>
-              </a:lnSpc>
-              <a:spcAft>
-                <a:spcPts val="0"/>
-              </a:spcAft>
-            </a:pPr>
-            <a:r>
-              <a:rPr sz="1600" b="1" i="0">
-                <a:solidFill>
-                  <a:srgbClr val="EAF0F8"/>
-                </a:solidFill>
-                <a:latin typeface="Arial"/>
-              </a:rPr>
-              <a:t>Salary relief</a:t>
+            <a:off x="6757416" y="3703320"/>
+            <a:ext cx="4489704" cy="1188720"/>
+          </a:xfrm>
+          <a:prstGeom prst="rect">
+            <a:avLst/>
+          </a:prstGeom>
+          <a:noFill/>
+        </p:spPr>
+        <p:txBody>
+          <a:bodyPr wrap="square" anchor="t" lIns="0" rIns="0" tIns="0" bIns="0">
+            <a:spAutoFit/>
+          </a:bodyPr>
+          <a:lstStyle/>
+          <a:p>
+            <a:pPr algn="l">
+              <a:lnSpc>
+                <a:spcPct val="109000"/>
+              </a:lnSpc>
+              <a:spcAft>
+                <a:spcPts val="400"/>
+              </a:spcAft>
+            </a:pPr>
+            <a:r>
+              <a:rPr sz="1300" b="1" i="0">
+                <a:solidFill>
+                  <a:srgbClr val="D9E1EF"/>
+                </a:solidFill>
+                <a:latin typeface="Arial"/>
+              </a:rPr>
+              <a:t>Built for the park. </a:t>
+            </a:r>
+            <a:r>
+              <a:rPr sz="1220" b="0" i="0">
+                <a:solidFill>
+                  <a:srgbClr val="93A0B6"/>
+                </a:solidFill>
+                <a:latin typeface="Arial"/>
+              </a:rPr>
+              <a:t>23% pull-air rate (82nd percentile). RHB pull-air plays to the Monster.</a:t>
             </a:r>
           </a:p>
         </p:txBody>
@@ -7998,36 +8004,45 @@
         </p:nvSpPr>
         <p:spPr>
           <a:xfrm>
-            <a:off x="8412480" y="3767328"/>
-            <a:ext cx="2999232" cy="1097280"/>
-          </a:xfrm>
-          <a:prstGeom prst="rect">
-            <a:avLst/>
-          </a:prstGeom>
-          <a:noFill/>
-        </p:spPr>
-        <p:txBody>
-          <a:bodyPr wrap="square" anchor="t" lIns="0" rIns="0" tIns="0" bIns="0">
-            <a:spAutoFit/>
-          </a:bodyPr>
-          <a:lstStyle/>
-          <a:p>
-            <a:pPr algn="l">
-              <a:lnSpc>
-                <a:spcPct val="110000"/>
+            <a:off x="566928" y="5257800"/>
+            <a:ext cx="11064240" cy="914400"/>
+          </a:xfrm>
+          <a:prstGeom prst="rect">
+            <a:avLst/>
+          </a:prstGeom>
+          <a:noFill/>
+        </p:spPr>
+        <p:txBody>
+          <a:bodyPr wrap="square" anchor="t" lIns="0" rIns="0" tIns="0" bIns="0">
+            <a:spAutoFit/>
+          </a:bodyPr>
+          <a:lstStyle/>
+          <a:p>
+            <a:pPr algn="l">
+              <a:lnSpc>
+                <a:spcPct val="115000"/>
               </a:lnSpc>
               <a:spcAft>
                 <a:spcPts val="400"/>
               </a:spcAft>
             </a:pPr>
             <a:r>
-              <a:rPr sz="1280" b="0" i="0">
-                <a:solidFill>
-                  <a:srgbClr val="93A0B6"/>
-                </a:solidFill>
-                <a:latin typeface="Arial"/>
-              </a:rPr>
-              <a:t>Attach Yoshida money where possible; free payroll for the 2027 window.</a:t>
+              <a:rPr sz="1400" b="1" i="0">
+                <a:solidFill>
+                  <a:srgbClr val="E3B14E"/>
+                </a:solidFill>
+                <a:latin typeface="Arial"/>
+              </a:rPr>
+              <a:t>The factory keeps producing:  </a:t>
+            </a:r>
+            <a:r>
+              <a:rPr sz="1300" b="0" i="0">
+                <a:solidFill>
+                  <a:srgbClr val="D9E1EF"/>
+                </a:solidFill>
+                <a:latin typeface="Arial"/>
+              </a:rPr>
+              <a:t>Tolle (6' 6", 250 lbs, 3.31 ERA / 3.24 FIP) and Bennett (6' 6", 234 lbs, 2.58 / 3.12) are bigger, more durable and better by FIP. Boston develops arms; it bought the bat it could not grow.</a:t>
             </a:r>
           </a:p>
         </p:txBody>
@@ -8035,57 +8050,6 @@
       <p:sp>
         <p:nvSpPr>
           <p:cNvPr id="17" name="TextBox 16"/>
-          <p:cNvSpPr txBox="1"/>
-          <p:nvPr/>
-        </p:nvSpPr>
-        <p:spPr>
-          <a:xfrm>
-            <a:off x="566928" y="5257800"/>
-            <a:ext cx="11064240" cy="457200"/>
-          </a:xfrm>
-          <a:prstGeom prst="rect">
-            <a:avLst/>
-          </a:prstGeom>
-          <a:noFill/>
-        </p:spPr>
-        <p:txBody>
-          <a:bodyPr wrap="square" anchor="t" lIns="0" rIns="0" tIns="0" bIns="0">
-            <a:spAutoFit/>
-          </a:bodyPr>
-          <a:lstStyle/>
-          <a:p>
-            <a:pPr algn="l">
-              <a:lnSpc>
-                <a:spcPct val="100000"/>
-              </a:lnSpc>
-              <a:spcAft>
-                <a:spcPts val="0"/>
-              </a:spcAft>
-            </a:pPr>
-            <a:r>
-              <a:rPr sz="1400" b="1" i="1">
-                <a:solidFill>
-                  <a:srgbClr val="EAF0F8"/>
-                </a:solidFill>
-                <a:latin typeface="Arial"/>
-              </a:rPr>
-              <a:t>Keep the arms. Cash the outfield. </a:t>
-            </a:r>
-            <a:r>
-              <a:rPr sz="1400" b="0" i="1">
-                <a:solidFill>
-                  <a:srgbClr val="93A0B6"/>
-                </a:solidFill>
-                <a:latin typeface="Arial"/>
-              </a:rPr>
-              <a:t>Build the 2027 lineup, don't rent the 2026 one.</a:t>
-            </a:r>
-          </a:p>
-        </p:txBody>
-      </p:sp>
-      <p:sp>
-        <p:nvSpPr>
-          <p:cNvPr id="18" name="TextBox 17"/>
           <p:cNvSpPr txBox="1"/>
           <p:nvPr/>
         </p:nvSpPr>
@@ -8143,786 +8107,6 @@
 </file>
 
 <file path=ppt/slides/slide17.xml><?xml version="1.0" encoding="utf-8"?>
-<p:sld xmlns:a="http://schemas.openxmlformats.org/drawingml/2006/main" xmlns:p="http://schemas.openxmlformats.org/presentationml/2006/main" xmlns:r="http://schemas.openxmlformats.org/officeDocument/2006/relationships">
-  <p:cSld>
-    <p:bg>
-      <p:bgPr>
-        <a:solidFill>
-          <a:srgbClr val="0B1220"/>
-        </a:solidFill>
-        <a:effectLst/>
-      </p:bgPr>
-    </p:bg>
-    <p:spTree>
-      <p:nvGrpSpPr>
-        <p:cNvPr id="1" name=""/>
-        <p:cNvGrpSpPr/>
-        <p:nvPr/>
-      </p:nvGrpSpPr>
-      <p:grpSpPr/>
-      <p:sp>
-        <p:nvSpPr>
-          <p:cNvPr id="2" name="TextBox 1"/>
-          <p:cNvSpPr txBox="1"/>
-          <p:nvPr/>
-        </p:nvSpPr>
-        <p:spPr>
-          <a:xfrm>
-            <a:off x="566928" y="384048"/>
-            <a:ext cx="10058400" cy="274320"/>
-          </a:xfrm>
-          <a:prstGeom prst="rect">
-            <a:avLst/>
-          </a:prstGeom>
-          <a:noFill/>
-        </p:spPr>
-        <p:txBody>
-          <a:bodyPr wrap="square" anchor="t" lIns="0" rIns="0" tIns="0" bIns="0">
-            <a:spAutoFit/>
-          </a:bodyPr>
-          <a:lstStyle/>
-          <a:p>
-            <a:pPr algn="l">
-              <a:lnSpc>
-                <a:spcPct val="100000"/>
-              </a:lnSpc>
-              <a:spcAft>
-                <a:spcPts val="0"/>
-              </a:spcAft>
-            </a:pPr>
-            <a:r>
-              <a:rPr sz="1200" b="1" i="0">
-                <a:solidFill>
-                  <a:srgbClr val="E8615A"/>
-                </a:solidFill>
-                <a:latin typeface="Courier New"/>
-              </a:rPr>
-              <a:t>// THE SEQUENCE</a:t>
-            </a:r>
-          </a:p>
-        </p:txBody>
-      </p:sp>
-      <p:sp>
-        <p:nvSpPr>
-          <p:cNvPr id="3" name="TextBox 2"/>
-          <p:cNvSpPr txBox="1"/>
-          <p:nvPr/>
-        </p:nvSpPr>
-        <p:spPr>
-          <a:xfrm>
-            <a:off x="566928" y="658368"/>
-            <a:ext cx="11064240" cy="868680"/>
-          </a:xfrm>
-          <a:prstGeom prst="rect">
-            <a:avLst/>
-          </a:prstGeom>
-          <a:noFill/>
-        </p:spPr>
-        <p:txBody>
-          <a:bodyPr wrap="square" anchor="t" lIns="0" rIns="0" tIns="0" bIns="0">
-            <a:spAutoFit/>
-          </a:bodyPr>
-          <a:lstStyle/>
-          <a:p>
-            <a:pPr algn="l">
-              <a:lnSpc>
-                <a:spcPct val="100000"/>
-              </a:lnSpc>
-              <a:spcAft>
-                <a:spcPts val="0"/>
-              </a:spcAft>
-            </a:pPr>
-            <a:r>
-              <a:rPr sz="3000" b="1" i="0">
-                <a:solidFill>
-                  <a:srgbClr val="EAF0F8"/>
-                </a:solidFill>
-                <a:latin typeface="Arial"/>
-              </a:rPr>
-              <a:t>Buy now, decide on Duran in the winter</a:t>
-            </a:r>
-          </a:p>
-        </p:txBody>
-      </p:sp>
-      <p:sp>
-        <p:nvSpPr>
-          <p:cNvPr id="4" name="Rounded Rectangle 3"/>
-          <p:cNvSpPr/>
-          <p:nvPr/>
-        </p:nvSpPr>
-        <p:spPr>
-          <a:xfrm>
-            <a:off x="640080" y="1801368"/>
-            <a:ext cx="457200" cy="457200"/>
-          </a:xfrm>
-          <a:prstGeom prst="roundRect">
-            <a:avLst>
-              <a:gd name="adj" fmla="val 18000"/>
-            </a:avLst>
-          </a:prstGeom>
-          <a:solidFill>
-            <a:srgbClr val="E8615A"/>
-          </a:solidFill>
-          <a:ln>
-            <a:noFill/>
-          </a:ln>
-          <a:effectLst/>
-        </p:spPr>
-        <p:style>
-          <a:lnRef idx="1">
-            <a:schemeClr val="accent1"/>
-          </a:lnRef>
-          <a:fillRef idx="3">
-            <a:schemeClr val="accent1"/>
-          </a:fillRef>
-          <a:effectRef idx="2">
-            <a:schemeClr val="accent1"/>
-          </a:effectRef>
-          <a:fontRef idx="minor">
-            <a:schemeClr val="lt1"/>
-          </a:fontRef>
-        </p:style>
-        <p:txBody>
-          <a:bodyPr rtlCol="0" anchor="ctr" wrap="none"/>
-          <a:lstStyle/>
-          <a:p>
-            <a:pPr algn="ctr"/>
-            <a:r>
-              <a:rPr sz="1800" b="1">
-                <a:solidFill>
-                  <a:srgbClr val="0B1220"/>
-                </a:solidFill>
-                <a:latin typeface="Courier New"/>
-              </a:rPr>
-              <a:t>1</a:t>
-            </a:r>
-          </a:p>
-        </p:txBody>
-      </p:sp>
-      <p:sp>
-        <p:nvSpPr>
-          <p:cNvPr id="5" name="TextBox 4"/>
-          <p:cNvSpPr txBox="1"/>
-          <p:nvPr/>
-        </p:nvSpPr>
-        <p:spPr>
-          <a:xfrm>
-            <a:off x="1280160" y="1783080"/>
-            <a:ext cx="6126480" cy="1005840"/>
-          </a:xfrm>
-          <a:prstGeom prst="rect">
-            <a:avLst/>
-          </a:prstGeom>
-          <a:noFill/>
-        </p:spPr>
-        <p:txBody>
-          <a:bodyPr wrap="square" anchor="t" lIns="0" rIns="0" tIns="0" bIns="0">
-            <a:spAutoFit/>
-          </a:bodyPr>
-          <a:lstStyle/>
-          <a:p>
-            <a:pPr algn="l">
-              <a:lnSpc>
-                <a:spcPct val="108000"/>
-              </a:lnSpc>
-              <a:spcAft>
-                <a:spcPts val="200"/>
-              </a:spcAft>
-            </a:pPr>
-            <a:r>
-              <a:rPr sz="1700" b="1" i="0">
-                <a:solidFill>
-                  <a:srgbClr val="EAF0F8"/>
-                </a:solidFill>
-                <a:latin typeface="Arial"/>
-              </a:rPr>
-              <a:t>At the deadline: buy targeted</a:t>
-            </a:r>
-          </a:p>
-          <a:p>
-            <a:pPr algn="l">
-              <a:lnSpc>
-                <a:spcPct val="108000"/>
-              </a:lnSpc>
-              <a:spcAft>
-                <a:spcPts val="200"/>
-              </a:spcAft>
-            </a:pPr>
-            <a:r>
-              <a:rPr sz="1350" b="0" i="0">
-                <a:solidFill>
-                  <a:srgbClr val="93A0B6"/>
-                </a:solidFill>
-                <a:latin typeface="Arial"/>
-              </a:rPr>
-              <a:t>A controllable infield bat and a reliever, funded from the pitching surplus. Keep the vets, they're playoff innings now.</a:t>
-            </a:r>
-          </a:p>
-        </p:txBody>
-      </p:sp>
-      <p:sp>
-        <p:nvSpPr>
-          <p:cNvPr id="6" name="Rounded Rectangle 5"/>
-          <p:cNvSpPr/>
-          <p:nvPr/>
-        </p:nvSpPr>
-        <p:spPr>
-          <a:xfrm>
-            <a:off x="640080" y="2971800"/>
-            <a:ext cx="457200" cy="457200"/>
-          </a:xfrm>
-          <a:prstGeom prst="roundRect">
-            <a:avLst>
-              <a:gd name="adj" fmla="val 18000"/>
-            </a:avLst>
-          </a:prstGeom>
-          <a:solidFill>
-            <a:srgbClr val="E8615A"/>
-          </a:solidFill>
-          <a:ln>
-            <a:noFill/>
-          </a:ln>
-          <a:effectLst/>
-        </p:spPr>
-        <p:style>
-          <a:lnRef idx="1">
-            <a:schemeClr val="accent1"/>
-          </a:lnRef>
-          <a:fillRef idx="3">
-            <a:schemeClr val="accent1"/>
-          </a:fillRef>
-          <a:effectRef idx="2">
-            <a:schemeClr val="accent1"/>
-          </a:effectRef>
-          <a:fontRef idx="minor">
-            <a:schemeClr val="lt1"/>
-          </a:fontRef>
-        </p:style>
-        <p:txBody>
-          <a:bodyPr rtlCol="0" anchor="ctr" wrap="none"/>
-          <a:lstStyle/>
-          <a:p>
-            <a:pPr algn="ctr"/>
-            <a:r>
-              <a:rPr sz="1800" b="1">
-                <a:solidFill>
-                  <a:srgbClr val="0B1220"/>
-                </a:solidFill>
-                <a:latin typeface="Courier New"/>
-              </a:rPr>
-              <a:t>2</a:t>
-            </a:r>
-          </a:p>
-        </p:txBody>
-      </p:sp>
-      <p:sp>
-        <p:nvSpPr>
-          <p:cNvPr id="7" name="TextBox 6"/>
-          <p:cNvSpPr txBox="1"/>
-          <p:nvPr/>
-        </p:nvSpPr>
-        <p:spPr>
-          <a:xfrm>
-            <a:off x="1280160" y="2953512"/>
-            <a:ext cx="6126480" cy="1005840"/>
-          </a:xfrm>
-          <a:prstGeom prst="rect">
-            <a:avLst/>
-          </a:prstGeom>
-          <a:noFill/>
-        </p:spPr>
-        <p:txBody>
-          <a:bodyPr wrap="square" anchor="t" lIns="0" rIns="0" tIns="0" bIns="0">
-            <a:spAutoFit/>
-          </a:bodyPr>
-          <a:lstStyle/>
-          <a:p>
-            <a:pPr algn="l">
-              <a:lnSpc>
-                <a:spcPct val="108000"/>
-              </a:lnSpc>
-              <a:spcAft>
-                <a:spcPts val="200"/>
-              </a:spcAft>
-            </a:pPr>
-            <a:r>
-              <a:rPr sz="1700" b="1" i="0">
-                <a:solidFill>
-                  <a:srgbClr val="EAF0F8"/>
-                </a:solidFill>
-                <a:latin typeface="Arial"/>
-              </a:rPr>
-              <a:t>Hold Duran through August</a:t>
-            </a:r>
-          </a:p>
-          <a:p>
-            <a:pPr algn="l">
-              <a:lnSpc>
-                <a:spcPct val="108000"/>
-              </a:lnSpc>
-              <a:spcAft>
-                <a:spcPts val="200"/>
-              </a:spcAft>
-            </a:pPr>
-            <a:r>
-              <a:rPr sz="1350" b="0" i="0">
-                <a:solidFill>
-                  <a:srgbClr val="93A0B6"/>
-                </a:solidFill>
-                <a:latin typeface="Arial"/>
-              </a:rPr>
-              <a:t>His value is at its nadir and his July contact quality (~.35 xwOBA) is already surging. Selling now cashes the slump.</a:t>
-            </a:r>
-          </a:p>
-        </p:txBody>
-      </p:sp>
-      <p:sp>
-        <p:nvSpPr>
-          <p:cNvPr id="8" name="Rounded Rectangle 7"/>
-          <p:cNvSpPr/>
-          <p:nvPr/>
-        </p:nvSpPr>
-        <p:spPr>
-          <a:xfrm>
-            <a:off x="640080" y="4142231"/>
-            <a:ext cx="457200" cy="457200"/>
-          </a:xfrm>
-          <a:prstGeom prst="roundRect">
-            <a:avLst>
-              <a:gd name="adj" fmla="val 18000"/>
-            </a:avLst>
-          </a:prstGeom>
-          <a:solidFill>
-            <a:srgbClr val="E8615A"/>
-          </a:solidFill>
-          <a:ln>
-            <a:noFill/>
-          </a:ln>
-          <a:effectLst/>
-        </p:spPr>
-        <p:style>
-          <a:lnRef idx="1">
-            <a:schemeClr val="accent1"/>
-          </a:lnRef>
-          <a:fillRef idx="3">
-            <a:schemeClr val="accent1"/>
-          </a:fillRef>
-          <a:effectRef idx="2">
-            <a:schemeClr val="accent1"/>
-          </a:effectRef>
-          <a:fontRef idx="minor">
-            <a:schemeClr val="lt1"/>
-          </a:fontRef>
-        </p:style>
-        <p:txBody>
-          <a:bodyPr rtlCol="0" anchor="ctr" wrap="none"/>
-          <a:lstStyle/>
-          <a:p>
-            <a:pPr algn="ctr"/>
-            <a:r>
-              <a:rPr sz="1800" b="1">
-                <a:solidFill>
-                  <a:srgbClr val="0B1220"/>
-                </a:solidFill>
-                <a:latin typeface="Courier New"/>
-              </a:rPr>
-              <a:t>3</a:t>
-            </a:r>
-          </a:p>
-        </p:txBody>
-      </p:sp>
-      <p:sp>
-        <p:nvSpPr>
-          <p:cNvPr id="9" name="TextBox 8"/>
-          <p:cNvSpPr txBox="1"/>
-          <p:nvPr/>
-        </p:nvSpPr>
-        <p:spPr>
-          <a:xfrm>
-            <a:off x="1280160" y="4123944"/>
-            <a:ext cx="6126480" cy="1005840"/>
-          </a:xfrm>
-          <a:prstGeom prst="rect">
-            <a:avLst/>
-          </a:prstGeom>
-          <a:noFill/>
-        </p:spPr>
-        <p:txBody>
-          <a:bodyPr wrap="square" anchor="t" lIns="0" rIns="0" tIns="0" bIns="0">
-            <a:spAutoFit/>
-          </a:bodyPr>
-          <a:lstStyle/>
-          <a:p>
-            <a:pPr algn="l">
-              <a:lnSpc>
-                <a:spcPct val="108000"/>
-              </a:lnSpc>
-              <a:spcAft>
-                <a:spcPts val="200"/>
-              </a:spcAft>
-            </a:pPr>
-            <a:r>
-              <a:rPr sz="1700" b="1" i="0">
-                <a:solidFill>
-                  <a:srgbClr val="EAF0F8"/>
-                </a:solidFill>
-                <a:latin typeface="Arial"/>
-              </a:rPr>
-              <a:t>Winter: re-price, then choose</a:t>
-            </a:r>
-          </a:p>
-          <a:p>
-            <a:pPr algn="l">
-              <a:lnSpc>
-                <a:spcPct val="108000"/>
-              </a:lnSpc>
-              <a:spcAft>
-                <a:spcPts val="200"/>
-              </a:spcAft>
-            </a:pPr>
-            <a:r>
-              <a:rPr sz="1350" b="0" i="0">
-                <a:solidFill>
-                  <a:srgbClr val="93A0B6"/>
-                </a:solidFill>
-                <a:latin typeface="Arial"/>
-              </a:rPr>
-              <a:t>Anthony healthy, jam returns. Rebound confirmed → extend or trade at full price. Erosion persists → sell at market. Either way, the 2027 OF is Anthony / Rafaela / Abreu.</a:t>
-            </a:r>
-          </a:p>
-        </p:txBody>
-      </p:sp>
-      <p:sp>
-        <p:nvSpPr>
-          <p:cNvPr id="10" name="Rounded Rectangle 9"/>
-          <p:cNvSpPr/>
-          <p:nvPr/>
-        </p:nvSpPr>
-        <p:spPr>
-          <a:xfrm>
-            <a:off x="7818120" y="1783080"/>
-            <a:ext cx="3794760" cy="3337560"/>
-          </a:xfrm>
-          <a:prstGeom prst="roundRect">
-            <a:avLst>
-              <a:gd name="adj" fmla="val 6000"/>
-            </a:avLst>
-          </a:prstGeom>
-          <a:solidFill>
-            <a:srgbClr val="1A2740"/>
-          </a:solidFill>
-          <a:ln>
-            <a:noFill/>
-          </a:ln>
-          <a:effectLst/>
-        </p:spPr>
-        <p:style>
-          <a:lnRef idx="1">
-            <a:schemeClr val="accent1"/>
-          </a:lnRef>
-          <a:fillRef idx="3">
-            <a:schemeClr val="accent1"/>
-          </a:fillRef>
-          <a:effectRef idx="2">
-            <a:schemeClr val="accent1"/>
-          </a:effectRef>
-          <a:fontRef idx="minor">
-            <a:schemeClr val="lt1"/>
-          </a:fontRef>
-        </p:style>
-        <p:txBody>
-          <a:bodyPr rtlCol="0" anchor="ctr"/>
-          <a:lstStyle/>
-          <a:p>
-            <a:pPr algn="ctr"/>
-          </a:p>
-        </p:txBody>
-      </p:sp>
-      <p:sp>
-        <p:nvSpPr>
-          <p:cNvPr id="11" name="TextBox 10"/>
-          <p:cNvSpPr txBox="1"/>
-          <p:nvPr/>
-        </p:nvSpPr>
-        <p:spPr>
-          <a:xfrm>
-            <a:off x="8092440" y="2011680"/>
-            <a:ext cx="3291840" cy="365760"/>
-          </a:xfrm>
-          <a:prstGeom prst="rect">
-            <a:avLst/>
-          </a:prstGeom>
-          <a:noFill/>
-        </p:spPr>
-        <p:txBody>
-          <a:bodyPr wrap="square" anchor="t" lIns="0" rIns="0" tIns="0" bIns="0">
-            <a:spAutoFit/>
-          </a:bodyPr>
-          <a:lstStyle/>
-          <a:p>
-            <a:pPr algn="l">
-              <a:lnSpc>
-                <a:spcPct val="100000"/>
-              </a:lnSpc>
-              <a:spcAft>
-                <a:spcPts val="0"/>
-              </a:spcAft>
-            </a:pPr>
-            <a:r>
-              <a:rPr sz="1250" b="1" i="0">
-                <a:solidFill>
-                  <a:srgbClr val="C9D2E3"/>
-                </a:solidFill>
-                <a:latin typeface="Arial"/>
-              </a:rPr>
-              <a:t>THE RETURN</a:t>
-            </a:r>
-          </a:p>
-        </p:txBody>
-      </p:sp>
-      <p:sp>
-        <p:nvSpPr>
-          <p:cNvPr id="12" name="TextBox 11"/>
-          <p:cNvSpPr txBox="1"/>
-          <p:nvPr/>
-        </p:nvSpPr>
-        <p:spPr>
-          <a:xfrm>
-            <a:off x="8092440" y="2487168"/>
-            <a:ext cx="3291840" cy="914400"/>
-          </a:xfrm>
-          <a:prstGeom prst="rect">
-            <a:avLst/>
-          </a:prstGeom>
-          <a:noFill/>
-        </p:spPr>
-        <p:txBody>
-          <a:bodyPr wrap="square" anchor="t" lIns="0" rIns="0" tIns="0" bIns="0">
-            <a:spAutoFit/>
-          </a:bodyPr>
-          <a:lstStyle/>
-          <a:p>
-            <a:pPr algn="l">
-              <a:lnSpc>
-                <a:spcPct val="105000"/>
-              </a:lnSpc>
-              <a:spcAft>
-                <a:spcPts val="200"/>
-              </a:spcAft>
-            </a:pPr>
-            <a:r>
-              <a:rPr sz="1300" b="1" i="0">
-                <a:solidFill>
-                  <a:srgbClr val="F0B8BC"/>
-                </a:solidFill>
-                <a:latin typeface="Arial"/>
-              </a:rPr>
-              <a:t>Sell now (nadir)</a:t>
-            </a:r>
-          </a:p>
-          <a:p>
-            <a:pPr algn="l">
-              <a:lnSpc>
-                <a:spcPct val="105000"/>
-              </a:lnSpc>
-              <a:spcAft>
-                <a:spcPts val="200"/>
-              </a:spcAft>
-            </a:pPr>
-            <a:r>
-              <a:rPr sz="1400" b="0" i="0">
-                <a:solidFill>
-                  <a:srgbClr val="F4F7FC"/>
-                </a:solidFill>
-                <a:latin typeface="Arial"/>
-              </a:rPr>
-              <a:t>~$10–15M · a 45-FV bat</a:t>
-            </a:r>
-          </a:p>
-        </p:txBody>
-      </p:sp>
-      <p:sp>
-        <p:nvSpPr>
-          <p:cNvPr id="13" name="TextBox 12"/>
-          <p:cNvSpPr txBox="1"/>
-          <p:nvPr/>
-        </p:nvSpPr>
-        <p:spPr>
-          <a:xfrm>
-            <a:off x="8092440" y="3520440"/>
-            <a:ext cx="3291840" cy="1005840"/>
-          </a:xfrm>
-          <a:prstGeom prst="rect">
-            <a:avLst/>
-          </a:prstGeom>
-          <a:noFill/>
-        </p:spPr>
-        <p:txBody>
-          <a:bodyPr wrap="square" anchor="t" lIns="0" rIns="0" tIns="0" bIns="0">
-            <a:spAutoFit/>
-          </a:bodyPr>
-          <a:lstStyle/>
-          <a:p>
-            <a:pPr algn="l">
-              <a:lnSpc>
-                <a:spcPct val="105000"/>
-              </a:lnSpc>
-              <a:spcAft>
-                <a:spcPts val="200"/>
-              </a:spcAft>
-            </a:pPr>
-            <a:r>
-              <a:rPr sz="1300" b="1" i="0">
-                <a:solidFill>
-                  <a:srgbClr val="A9E5B5"/>
-                </a:solidFill>
-                <a:latin typeface="Arial"/>
-              </a:rPr>
-              <a:t>Sell after rebound</a:t>
-            </a:r>
-          </a:p>
-          <a:p>
-            <a:pPr algn="l">
-              <a:lnSpc>
-                <a:spcPct val="105000"/>
-              </a:lnSpc>
-              <a:spcAft>
-                <a:spcPts val="200"/>
-              </a:spcAft>
-            </a:pPr>
-            <a:r>
-              <a:rPr sz="1400" b="0" i="0">
-                <a:solidFill>
-                  <a:srgbClr val="F4F7FC"/>
-                </a:solidFill>
-                <a:latin typeface="Arial"/>
-              </a:rPr>
-              <a:t>~$28M · a 50-FV, top-100</a:t>
-            </a:r>
-          </a:p>
-          <a:p>
-            <a:pPr algn="l">
-              <a:lnSpc>
-                <a:spcPct val="105000"/>
-              </a:lnSpc>
-              <a:spcAft>
-                <a:spcPts val="200"/>
-              </a:spcAft>
-            </a:pPr>
-            <a:r>
-              <a:rPr sz="1400" b="0" i="0">
-                <a:solidFill>
-                  <a:srgbClr val="F4F7FC"/>
-                </a:solidFill>
-                <a:latin typeface="Arial"/>
-              </a:rPr>
-              <a:t>controllable talent</a:t>
-            </a:r>
-          </a:p>
-        </p:txBody>
-      </p:sp>
-      <p:sp>
-        <p:nvSpPr>
-          <p:cNvPr id="14" name="TextBox 13"/>
-          <p:cNvSpPr txBox="1"/>
-          <p:nvPr/>
-        </p:nvSpPr>
-        <p:spPr>
-          <a:xfrm>
-            <a:off x="8092440" y="4617720"/>
-            <a:ext cx="3291840" cy="457200"/>
-          </a:xfrm>
-          <a:prstGeom prst="rect">
-            <a:avLst/>
-          </a:prstGeom>
-          <a:noFill/>
-        </p:spPr>
-        <p:txBody>
-          <a:bodyPr wrap="square" anchor="t" lIns="0" rIns="0" tIns="0" bIns="0">
-            <a:spAutoFit/>
-          </a:bodyPr>
-          <a:lstStyle/>
-          <a:p>
-            <a:pPr algn="l">
-              <a:lnSpc>
-                <a:spcPct val="105000"/>
-              </a:lnSpc>
-              <a:spcAft>
-                <a:spcPts val="400"/>
-              </a:spcAft>
-            </a:pPr>
-            <a:r>
-              <a:rPr sz="1150" b="0" i="1">
-                <a:solidFill>
-                  <a:srgbClr val="C9D2E3"/>
-                </a:solidFill>
-                <a:latin typeface="Arial"/>
-              </a:rPr>
-              <a:t>One grade of return = the reason to wait.</a:t>
-            </a:r>
-          </a:p>
-        </p:txBody>
-      </p:sp>
-      <p:sp>
-        <p:nvSpPr>
-          <p:cNvPr id="15" name="TextBox 14"/>
-          <p:cNvSpPr txBox="1"/>
-          <p:nvPr/>
-        </p:nvSpPr>
-        <p:spPr>
-          <a:xfrm>
-            <a:off x="566928" y="6510528"/>
-            <a:ext cx="11064240" cy="274320"/>
-          </a:xfrm>
-          <a:prstGeom prst="rect">
-            <a:avLst/>
-          </a:prstGeom>
-          <a:noFill/>
-        </p:spPr>
-        <p:txBody>
-          <a:bodyPr wrap="square" anchor="t" lIns="0" rIns="0" tIns="0" bIns="0">
-            <a:spAutoFit/>
-          </a:bodyPr>
-          <a:lstStyle/>
-          <a:p>
-            <a:pPr algn="l">
-              <a:lnSpc>
-                <a:spcPct val="100000"/>
-              </a:lnSpc>
-              <a:spcAft>
-                <a:spcPts val="0"/>
-              </a:spcAft>
-            </a:pPr>
-            <a:r>
-              <a:rPr sz="800" b="1" i="0">
-                <a:solidFill>
-                  <a:srgbClr val="E8615A"/>
-                </a:solidFill>
-                <a:latin typeface="Courier New"/>
-              </a:rPr>
-              <a:t>BOS // OUTFIELD STRATEGY</a:t>
-            </a:r>
-            <a:r>
-              <a:rPr sz="800" b="0" i="0">
-                <a:solidFill>
-                  <a:srgbClr val="5E6B84"/>
-                </a:solidFill>
-                <a:latin typeface="Courier New"/>
-              </a:rPr>
-              <a:t>   STATCAST / FANGRAPHS / MLB STATS API / SPOTRAC · JULY 2026</a:t>
-            </a:r>
-          </a:p>
-        </p:txBody>
-      </p:sp>
-    </p:spTree>
-  </p:cSld>
-  <p:clrMapOvr>
-    <a:masterClrMapping/>
-  </p:clrMapOvr>
-</p:sld>
-</file>
-
-<file path=ppt/slides/slide18.xml><?xml version="1.0" encoding="utf-8"?>
 <p:sld xmlns:a="http://schemas.openxmlformats.org/drawingml/2006/main" xmlns:p="http://schemas.openxmlformats.org/presentationml/2006/main" xmlns:r="http://schemas.openxmlformats.org/officeDocument/2006/relationships">
   <p:cSld>
     <p:bg>

</xml_diff>

<commit_message>
Battery map redesigned without Crochet; Mead's Fenway-adjusted line
- Crochet dropped from the battery chart (13-17 IP rehab sample, and
  the 2025 substitution mixed seasons); figure rebuilt cleanly: five
  starters, alternating row bands, RA9 + IP labels on every point,
  staff-average line, white-edged dots, natural proportions
- Fenway projection for Mead: replaying his Monster-zone contact as
  wall doubles moves his .376 wOBA to .395 if every such ball played
  at Fenway, about .386 on a realistic half-home schedule (+10 to +19
  points from the park, linear weights on reclassified outcomes).
  Stated in the article with the method, on the deck's Fenway-fit
  card, and stored in acquisition.json

Co-Authored-By: Claude Fable 5 <noreply@anthropic.com>
</commit_message>
<xml_diff>
--- a/outputs/Red_Sox_Trade_Deadline.pptx
+++ b/outputs/Red_Sox_Trade_Deadline.pptx
@@ -5418,7 +5418,7 @@
         <p:spPr>
           <a:xfrm>
             <a:off x="365760" y="1554480"/>
-            <a:ext cx="7315200" cy="3384148"/>
+            <a:ext cx="7315200" cy="3444610"/>
           </a:xfrm>
           <a:prstGeom prst="rect">
             <a:avLst/>
@@ -7048,7 +7048,7 @@
                 </a:solidFill>
                 <a:latin typeface="Arial"/>
               </a:rPr>
-              <a:t>23% pull-air rate, 82nd percentile, with a .846 wOBA on pulled air balls. RHB pull-air plays to the Monster.</a:t>
+              <a:t>23% pull-air rate (82nd pctile). Replaying his Monster-zone contact as wall doubles takes him from a .376 wOBA to about .386 on a half-home schedule.</a:t>
             </a:r>
           </a:p>
         </p:txBody>

</xml_diff>

<commit_message>
Package options per trade lane; Mead's top-100 pedigree
- Each trade now carries package options and lane alternatives, all
  with live stat lines: Weaver (prospects-only or the Bello version;
  premium alt Varland, controllable at 1.04/1.41; cheap rental alt
  Tyler Rogers), Wacha (40 FV, Gausman buy-low alt), Neto (arms-only
  Tolle+Bennett+45, or the Mayer version since Neto blocks him anyway;
  cheaper lane Otto Lopez, budget Ezequiel Duran)
- Compact article menu carries the options inline; contracts footer
  and candidate pools updated
- Mead identified as a former consensus top-100 prospect in the
  article, the deal card, and the trade-comparison slide

Co-Authored-By: Claude Fable 5 <noreply@anthropic.com>
</commit_message>
<xml_diff>
--- a/outputs/Red_Sox_Trade_Deadline.pptx
+++ b/outputs/Red_Sox_Trade_Deadline.pptx
@@ -6941,7 +6941,7 @@
                 </a:solidFill>
                 <a:latin typeface="Arial"/>
               </a:rPr>
-              <a:t>Curtis Mead (25) from Washington for Connelly Early: one surplus arm for a 134 wRC+ infield bat with years of club control.</a:t>
+              <a:t>Curtis Mead (25) from Washington for Connelly Early: one surplus arm for a former top-100 prospect at a 134 wRC+ with years of club control.</a:t>
             </a:r>
           </a:p>
         </p:txBody>
@@ -7894,7 +7894,7 @@
                 </a:solidFill>
                 <a:latin typeface="Arial"/>
               </a:rPr>
-              <a:t>134 wRC+ at 25, backed by a .359 xwOBA. Years of club control at the position the audit flagged.</a:t>
+              <a:t>Former top-100 prospect, 134 wRC+ at 25, backed by a .359 xwOBA. Years of club control at the position the audit flagged.</a:t>
             </a:r>
           </a:p>
         </p:txBody>

</xml_diff>

<commit_message>
Pitching side of the regression watch: green arrows only
- Rotation screened against career marks (40+ IP, 8+ starts): Gray
  0.80 runs under his career at 36, Suarez 0.23 under; Tolle and
  Bennett shown as rookies with no baseline; Early excluded (traded),
  Crochet and Bello excluded by the green-only rule since
  underperformers are not regression candidates (stated on the chart)
- Fixed the pool bug that silently dropped young starters (the AAAA
  prospect filter was pre-filtering the watch's source table)
- Article, memo data, and the deck regulars card carry the arms;
  chart caption states both screens and the green-only rule

Co-Authored-By: Claude Fable 5 <noreply@anthropic.com>
</commit_message>
<xml_diff>
--- a/outputs/Red_Sox_Trade_Deadline.pptx
+++ b/outputs/Red_Sox_Trade_Deadline.pptx
@@ -4085,7 +4085,7 @@
         <p:spPr>
           <a:xfrm>
             <a:off x="365760" y="1600200"/>
-            <a:ext cx="7315200" cy="3257028"/>
+            <a:ext cx="7315200" cy="2434241"/>
           </a:xfrm>
           <a:prstGeom prst="rect">
             <a:avLst/>
@@ -4408,7 +4408,7 @@
                 </a:solidFill>
                 <a:latin typeface="Arial"/>
               </a:rPr>
-              <a:t>Same screen on the everyday lineup: Contreras +130 OPS pts, Rafaela +76 OPS pts. Expect good, not scorching, from here.</a:t>
+              <a:t>Same screen, lineup and rotation: Contreras +130 OPS pts, Rafaela +76 OPS pts; Gray and Suarez are also under their career ERAs. Expect good, not scorching, from here.</a:t>
             </a:r>
           </a:p>
         </p:txBody>

</xml_diff>

<commit_message>
Version 3 edits saved; closer slide rebuilt as a scoreboard
- All v3 title edits ported: Red Sox Are Back From The Dead / Buy,
  Nibble At The Edges / Duran Will Be Back / Aging Not A Factor For
  Jarren / Left Field Is A Black Hole In 2026 / Regression Candidates /
  Possible Trades / New Acquisition: Mead Breakdown, and the rest
- Menu card edits from the post assets: 'Mid level starter' label,
  Neto card notes it blocks Mayer or Arias, walk-away card covers
  Langeliers (torn meniscus, 10-day IL) and Hunter Goodman, whose
  price now spikes
- Closing slide rebuilt: 'What I'd Do Before August 3' with a live
  scoreboard band (playoff odds, run differential, days left, and the
  39% base-rate stat), three numbered verdicts, and the frozen-
  predictions line with the site URL

Co-Authored-By: Claude Fable 5 <noreply@anthropic.com>
</commit_message>
<xml_diff>
--- a/outputs/Red_Sox_Trade_Deadline.pptx
+++ b/outputs/Red_Sox_Trade_Deadline.pptx
@@ -3450,7 +3450,7 @@
                 </a:solidFill>
                 <a:latin typeface="Arial"/>
               </a:rPr>
-              <a:t>The roster's biggest hole is the Duran slump itself</a:t>
+              <a:t>Left Field Is A Black Hole In 2026</a:t>
             </a:r>
           </a:p>
         </p:txBody>
@@ -4063,7 +4063,7 @@
                 </a:solidFill>
                 <a:latin typeface="Arial"/>
               </a:rPr>
-              <a:t>Career years everywhere. Could mean regression</a:t>
+              <a:t>Regression Candidates</a:t>
             </a:r>
           </a:p>
         </p:txBody>
@@ -4783,7 +4783,7 @@
                 </a:solidFill>
                 <a:latin typeface="Arial"/>
               </a:rPr>
-              <a:t>Career-year first halves usually give it back</a:t>
+              <a:t>Career-year First Halves Usually Give Back</a:t>
             </a:r>
           </a:p>
         </p:txBody>
@@ -5902,7 +5902,7 @@
                 </a:solidFill>
                 <a:latin typeface="Arial"/>
               </a:rPr>
-              <a:t>Three trades that fit, and one walk-away</a:t>
+              <a:t>Possible Trades</a:t>
             </a:r>
           </a:p>
         </p:txBody>
@@ -6166,7 +6166,7 @@
                 </a:solidFill>
                 <a:latin typeface="Arial"/>
               </a:rPr>
-              <a:t>2 · THE INNINGS · FILLS EARLY'S SLOT</a:t>
+              <a:t>2 · MID LEVEL STARTER</a:t>
             </a:r>
           </a:p>
         </p:txBody>
@@ -6424,7 +6424,7 @@
                 </a:solidFill>
                 <a:latin typeface="Arial"/>
               </a:rPr>
-              <a:t>For Tolle + Bennett + a 45 FV: two arms out of a winning rotation midseason. Right for the franchise window, and still there in the winter. Controlled through 2029.</a:t>
+              <a:t>For Tolle / Bennett + a 45 FV: two arms out of a winning rotation midseason. Right for the franchise window, and still there in the winter. Blocks Mayer or Arias as well. Controlled through 2029.</a:t>
             </a:r>
           </a:p>
         </p:txBody>
@@ -6556,7 +6556,7 @@
                 </a:solidFill>
                 <a:latin typeface="Arial"/>
               </a:rPr>
-              <a:t>C Shea Langeliers (ATH)</a:t>
+              <a:t>C Shea Langeliers (ATH) / Hunter Goodman (COL)</a:t>
             </a:r>
           </a:p>
         </p:txBody>
@@ -6598,7 +6598,7 @@
                 </a:solidFill>
                 <a:latin typeface="Arial"/>
               </a:rPr>
-              <a:t>The battery map was the veto, and the market agreed: torn meniscus, 10-day IL on July 26. Boston was right not to pay for a catcher bat it never needed.</a:t>
+              <a:t>Not worth overpaying for either. Langeliers just hit the 10-day IL with a torn meniscus, so Goodman's price shoots through the roof. Boston was right not to pay for a catcher bat it never needed.</a:t>
             </a:r>
           </a:p>
         </p:txBody>
@@ -6810,7 +6810,7 @@
                 </a:solidFill>
                 <a:latin typeface="Arial"/>
               </a:rPr>
-              <a:t>They made one: Mead for Early</a:t>
+              <a:t>New Acquisition: Mead Breakdown</a:t>
             </a:r>
           </a:p>
         </p:txBody>
@@ -8132,7 +8132,7 @@
         </p:nvSpPr>
         <p:spPr>
           <a:xfrm>
-            <a:off x="566928" y="640080"/>
+            <a:off x="566928" y="566928"/>
             <a:ext cx="310896" cy="310896"/>
           </a:xfrm>
           <a:prstGeom prst="roundRect">
@@ -8178,7 +8178,7 @@
         </p:nvSpPr>
         <p:spPr>
           <a:xfrm>
-            <a:off x="960120" y="621792"/>
+            <a:off x="960120" y="548640"/>
             <a:ext cx="9144000" cy="365760"/>
           </a:xfrm>
           <a:prstGeom prst="rect">
@@ -8214,14 +8214,440 @@
       </p:sp>
       <p:sp>
         <p:nvSpPr>
-          <p:cNvPr id="4" name="Rounded Rectangle 3"/>
+          <p:cNvPr id="4" name="TextBox 3"/>
+          <p:cNvSpPr txBox="1"/>
+          <p:nvPr/>
+        </p:nvSpPr>
+        <p:spPr>
+          <a:xfrm>
+            <a:off x="566928" y="960120"/>
+            <a:ext cx="11064240" cy="822960"/>
+          </a:xfrm>
+          <a:prstGeom prst="rect">
+            <a:avLst/>
+          </a:prstGeom>
+          <a:noFill/>
+        </p:spPr>
+        <p:txBody>
+          <a:bodyPr wrap="square" anchor="t" lIns="0" rIns="0" tIns="0" bIns="0">
+            <a:spAutoFit/>
+          </a:bodyPr>
+          <a:lstStyle/>
+          <a:p>
+            <a:pPr algn="l">
+              <a:lnSpc>
+                <a:spcPct val="100000"/>
+              </a:lnSpc>
+              <a:spcAft>
+                <a:spcPts val="0"/>
+              </a:spcAft>
+            </a:pPr>
+            <a:r>
+              <a:rPr sz="4000" b="1" i="0">
+                <a:solidFill>
+                  <a:srgbClr val="F4F7FC"/>
+                </a:solidFill>
+                <a:latin typeface="Arial"/>
+              </a:rPr>
+              <a:t>What I'd Do Before August 3</a:t>
+            </a:r>
+          </a:p>
+        </p:txBody>
+      </p:sp>
+      <p:sp>
+        <p:nvSpPr>
+          <p:cNvPr id="5" name="Rounded Rectangle 4"/>
           <p:cNvSpPr/>
           <p:nvPr/>
         </p:nvSpPr>
         <p:spPr>
           <a:xfrm>
-            <a:off x="640080" y="1837943"/>
-            <a:ext cx="164592" cy="164592"/>
+            <a:off x="566928" y="1874519"/>
+            <a:ext cx="11064240" cy="1371600"/>
+          </a:xfrm>
+          <a:prstGeom prst="roundRect">
+            <a:avLst>
+              <a:gd name="adj" fmla="val 6000"/>
+            </a:avLst>
+          </a:prstGeom>
+          <a:solidFill>
+            <a:srgbClr val="121E33"/>
+          </a:solidFill>
+          <a:ln w="12700">
+            <a:solidFill>
+              <a:srgbClr val="26334E"/>
+            </a:solidFill>
+          </a:ln>
+          <a:effectLst/>
+        </p:spPr>
+        <p:style>
+          <a:lnRef idx="1">
+            <a:schemeClr val="accent1"/>
+          </a:lnRef>
+          <a:fillRef idx="3">
+            <a:schemeClr val="accent1"/>
+          </a:fillRef>
+          <a:effectRef idx="2">
+            <a:schemeClr val="accent1"/>
+          </a:effectRef>
+          <a:fontRef idx="minor">
+            <a:schemeClr val="lt1"/>
+          </a:fontRef>
+        </p:style>
+        <p:txBody>
+          <a:bodyPr rtlCol="0" anchor="ctr"/>
+          <a:lstStyle/>
+          <a:p>
+            <a:pPr algn="ctr"/>
+          </a:p>
+        </p:txBody>
+      </p:sp>
+      <p:sp>
+        <p:nvSpPr>
+          <p:cNvPr id="6" name="TextBox 5"/>
+          <p:cNvSpPr txBox="1"/>
+          <p:nvPr/>
+        </p:nvSpPr>
+        <p:spPr>
+          <a:xfrm>
+            <a:off x="868680" y="2057400"/>
+            <a:ext cx="2606040" cy="640080"/>
+          </a:xfrm>
+          <a:prstGeom prst="rect">
+            <a:avLst/>
+          </a:prstGeom>
+          <a:noFill/>
+        </p:spPr>
+        <p:txBody>
+          <a:bodyPr wrap="square" anchor="t" lIns="0" rIns="0" tIns="0" bIns="0">
+            <a:spAutoFit/>
+          </a:bodyPr>
+          <a:lstStyle/>
+          <a:p>
+            <a:pPr algn="l">
+              <a:lnSpc>
+                <a:spcPct val="100000"/>
+              </a:lnSpc>
+              <a:spcAft>
+                <a:spcPts val="0"/>
+              </a:spcAft>
+            </a:pPr>
+            <a:r>
+              <a:rPr sz="3400" b="1" i="0">
+                <a:solidFill>
+                  <a:srgbClr val="E8615A"/>
+                </a:solidFill>
+                <a:latin typeface="Courier New"/>
+              </a:rPr>
+              <a:t>77%</a:t>
+            </a:r>
+          </a:p>
+        </p:txBody>
+      </p:sp>
+      <p:sp>
+        <p:nvSpPr>
+          <p:cNvPr id="7" name="TextBox 6"/>
+          <p:cNvSpPr txBox="1"/>
+          <p:nvPr/>
+        </p:nvSpPr>
+        <p:spPr>
+          <a:xfrm>
+            <a:off x="868680" y="2761488"/>
+            <a:ext cx="2606040" cy="365760"/>
+          </a:xfrm>
+          <a:prstGeom prst="rect">
+            <a:avLst/>
+          </a:prstGeom>
+          <a:noFill/>
+        </p:spPr>
+        <p:txBody>
+          <a:bodyPr wrap="square" anchor="t" lIns="0" rIns="0" tIns="0" bIns="0">
+            <a:spAutoFit/>
+          </a:bodyPr>
+          <a:lstStyle/>
+          <a:p>
+            <a:pPr algn="l">
+              <a:lnSpc>
+                <a:spcPct val="100000"/>
+              </a:lnSpc>
+              <a:spcAft>
+                <a:spcPts val="0"/>
+              </a:spcAft>
+            </a:pPr>
+            <a:r>
+              <a:rPr sz="950" b="1" i="0">
+                <a:solidFill>
+                  <a:srgbClr val="8C97AC"/>
+                </a:solidFill>
+                <a:latin typeface="Courier New"/>
+              </a:rPr>
+              <a:t>PLAYOFF ODDS</a:t>
+            </a:r>
+          </a:p>
+        </p:txBody>
+      </p:sp>
+      <p:sp>
+        <p:nvSpPr>
+          <p:cNvPr id="8" name="TextBox 7"/>
+          <p:cNvSpPr txBox="1"/>
+          <p:nvPr/>
+        </p:nvSpPr>
+        <p:spPr>
+          <a:xfrm>
+            <a:off x="3675888" y="2057400"/>
+            <a:ext cx="2606040" cy="640080"/>
+          </a:xfrm>
+          <a:prstGeom prst="rect">
+            <a:avLst/>
+          </a:prstGeom>
+          <a:noFill/>
+        </p:spPr>
+        <p:txBody>
+          <a:bodyPr wrap="square" anchor="t" lIns="0" rIns="0" tIns="0" bIns="0">
+            <a:spAutoFit/>
+          </a:bodyPr>
+          <a:lstStyle/>
+          <a:p>
+            <a:pPr algn="l">
+              <a:lnSpc>
+                <a:spcPct val="100000"/>
+              </a:lnSpc>
+              <a:spcAft>
+                <a:spcPts val="0"/>
+              </a:spcAft>
+            </a:pPr>
+            <a:r>
+              <a:rPr sz="3400" b="1" i="0">
+                <a:solidFill>
+                  <a:srgbClr val="F4F7FC"/>
+                </a:solidFill>
+                <a:latin typeface="Courier New"/>
+              </a:rPr>
+              <a:t>+41</a:t>
+            </a:r>
+          </a:p>
+        </p:txBody>
+      </p:sp>
+      <p:sp>
+        <p:nvSpPr>
+          <p:cNvPr id="9" name="TextBox 8"/>
+          <p:cNvSpPr txBox="1"/>
+          <p:nvPr/>
+        </p:nvSpPr>
+        <p:spPr>
+          <a:xfrm>
+            <a:off x="3675888" y="2761488"/>
+            <a:ext cx="2606040" cy="365760"/>
+          </a:xfrm>
+          <a:prstGeom prst="rect">
+            <a:avLst/>
+          </a:prstGeom>
+          <a:noFill/>
+        </p:spPr>
+        <p:txBody>
+          <a:bodyPr wrap="square" anchor="t" lIns="0" rIns="0" tIns="0" bIns="0">
+            <a:spAutoFit/>
+          </a:bodyPr>
+          <a:lstStyle/>
+          <a:p>
+            <a:pPr algn="l">
+              <a:lnSpc>
+                <a:spcPct val="100000"/>
+              </a:lnSpc>
+              <a:spcAft>
+                <a:spcPts val="0"/>
+              </a:spcAft>
+            </a:pPr>
+            <a:r>
+              <a:rPr sz="950" b="1" i="0">
+                <a:solidFill>
+                  <a:srgbClr val="8C97AC"/>
+                </a:solidFill>
+                <a:latin typeface="Courier New"/>
+              </a:rPr>
+              <a:t>RUN DIFF</a:t>
+            </a:r>
+          </a:p>
+        </p:txBody>
+      </p:sp>
+      <p:sp>
+        <p:nvSpPr>
+          <p:cNvPr id="10" name="TextBox 9"/>
+          <p:cNvSpPr txBox="1"/>
+          <p:nvPr/>
+        </p:nvSpPr>
+        <p:spPr>
+          <a:xfrm>
+            <a:off x="6483096" y="2057400"/>
+            <a:ext cx="2606040" cy="640080"/>
+          </a:xfrm>
+          <a:prstGeom prst="rect">
+            <a:avLst/>
+          </a:prstGeom>
+          <a:noFill/>
+        </p:spPr>
+        <p:txBody>
+          <a:bodyPr wrap="square" anchor="t" lIns="0" rIns="0" tIns="0" bIns="0">
+            <a:spAutoFit/>
+          </a:bodyPr>
+          <a:lstStyle/>
+          <a:p>
+            <a:pPr algn="l">
+              <a:lnSpc>
+                <a:spcPct val="100000"/>
+              </a:lnSpc>
+              <a:spcAft>
+                <a:spcPts val="0"/>
+              </a:spcAft>
+            </a:pPr>
+            <a:r>
+              <a:rPr sz="3400" b="1" i="0">
+                <a:solidFill>
+                  <a:srgbClr val="F4F7FC"/>
+                </a:solidFill>
+                <a:latin typeface="Courier New"/>
+              </a:rPr>
+              <a:t>8</a:t>
+            </a:r>
+          </a:p>
+        </p:txBody>
+      </p:sp>
+      <p:sp>
+        <p:nvSpPr>
+          <p:cNvPr id="11" name="TextBox 10"/>
+          <p:cNvSpPr txBox="1"/>
+          <p:nvPr/>
+        </p:nvSpPr>
+        <p:spPr>
+          <a:xfrm>
+            <a:off x="6483096" y="2761488"/>
+            <a:ext cx="2606040" cy="365760"/>
+          </a:xfrm>
+          <a:prstGeom prst="rect">
+            <a:avLst/>
+          </a:prstGeom>
+          <a:noFill/>
+        </p:spPr>
+        <p:txBody>
+          <a:bodyPr wrap="square" anchor="t" lIns="0" rIns="0" tIns="0" bIns="0">
+            <a:spAutoFit/>
+          </a:bodyPr>
+          <a:lstStyle/>
+          <a:p>
+            <a:pPr algn="l">
+              <a:lnSpc>
+                <a:spcPct val="100000"/>
+              </a:lnSpc>
+              <a:spcAft>
+                <a:spcPts val="0"/>
+              </a:spcAft>
+            </a:pPr>
+            <a:r>
+              <a:rPr sz="950" b="1" i="0">
+                <a:solidFill>
+                  <a:srgbClr val="8C97AC"/>
+                </a:solidFill>
+                <a:latin typeface="Courier New"/>
+              </a:rPr>
+              <a:t>DAYS LEFT</a:t>
+            </a:r>
+          </a:p>
+        </p:txBody>
+      </p:sp>
+      <p:sp>
+        <p:nvSpPr>
+          <p:cNvPr id="12" name="TextBox 11"/>
+          <p:cNvSpPr txBox="1"/>
+          <p:nvPr/>
+        </p:nvSpPr>
+        <p:spPr>
+          <a:xfrm>
+            <a:off x="9290304" y="2057400"/>
+            <a:ext cx="2606040" cy="640080"/>
+          </a:xfrm>
+          <a:prstGeom prst="rect">
+            <a:avLst/>
+          </a:prstGeom>
+          <a:noFill/>
+        </p:spPr>
+        <p:txBody>
+          <a:bodyPr wrap="square" anchor="t" lIns="0" rIns="0" tIns="0" bIns="0">
+            <a:spAutoFit/>
+          </a:bodyPr>
+          <a:lstStyle/>
+          <a:p>
+            <a:pPr algn="l">
+              <a:lnSpc>
+                <a:spcPct val="100000"/>
+              </a:lnSpc>
+              <a:spcAft>
+                <a:spcPts val="0"/>
+              </a:spcAft>
+            </a:pPr>
+            <a:r>
+              <a:rPr sz="3400" b="1" i="0">
+                <a:solidFill>
+                  <a:srgbClr val="F4F7FC"/>
+                </a:solidFill>
+                <a:latin typeface="Courier New"/>
+              </a:rPr>
+              <a:t>39%</a:t>
+            </a:r>
+          </a:p>
+        </p:txBody>
+      </p:sp>
+      <p:sp>
+        <p:nvSpPr>
+          <p:cNvPr id="13" name="TextBox 12"/>
+          <p:cNvSpPr txBox="1"/>
+          <p:nvPr/>
+        </p:nvSpPr>
+        <p:spPr>
+          <a:xfrm>
+            <a:off x="9290304" y="2761488"/>
+            <a:ext cx="2606040" cy="365760"/>
+          </a:xfrm>
+          <a:prstGeom prst="rect">
+            <a:avLst/>
+          </a:prstGeom>
+          <a:noFill/>
+        </p:spPr>
+        <p:txBody>
+          <a:bodyPr wrap="square" anchor="t" lIns="0" rIns="0" tIns="0" bIns="0">
+            <a:spAutoFit/>
+          </a:bodyPr>
+          <a:lstStyle/>
+          <a:p>
+            <a:pPr algn="l">
+              <a:lnSpc>
+                <a:spcPct val="100000"/>
+              </a:lnSpc>
+              <a:spcAft>
+                <a:spcPts val="0"/>
+              </a:spcAft>
+            </a:pPr>
+            <a:r>
+              <a:rPr sz="950" b="1" i="0">
+                <a:solidFill>
+                  <a:srgbClr val="8C97AC"/>
+                </a:solidFill>
+                <a:latin typeface="Courier New"/>
+              </a:rPr>
+              <a:t>OF A CAREER-BEST HALF SURVIVES, HISTORICALLY</a:t>
+            </a:r>
+          </a:p>
+        </p:txBody>
+      </p:sp>
+      <p:sp>
+        <p:nvSpPr>
+          <p:cNvPr id="14" name="Rounded Rectangle 13"/>
+          <p:cNvSpPr/>
+          <p:nvPr/>
+        </p:nvSpPr>
+        <p:spPr>
+          <a:xfrm>
+            <a:off x="640080" y="3630168"/>
+            <a:ext cx="384048" cy="384048"/>
           </a:xfrm>
           <a:prstGeom prst="roundRect">
             <a:avLst>
@@ -8251,23 +8677,32 @@
           </a:fontRef>
         </p:style>
         <p:txBody>
-          <a:bodyPr rtlCol="0" anchor="ctr"/>
+          <a:bodyPr rtlCol="0" anchor="ctr" wrap="none"/>
           <a:lstStyle/>
           <a:p>
             <a:pPr algn="ctr"/>
-          </a:p>
-        </p:txBody>
-      </p:sp>
-      <p:sp>
-        <p:nvSpPr>
-          <p:cNvPr id="5" name="TextBox 4"/>
-          <p:cNvSpPr txBox="1"/>
-          <p:nvPr/>
-        </p:nvSpPr>
-        <p:spPr>
-          <a:xfrm>
-            <a:off x="960120" y="1783080"/>
-            <a:ext cx="10424160" cy="914400"/>
+            <a:r>
+              <a:rPr sz="1600" b="1">
+                <a:solidFill>
+                  <a:srgbClr val="0B1220"/>
+                </a:solidFill>
+                <a:latin typeface="Courier New"/>
+              </a:rPr>
+              <a:t>1</a:t>
+            </a:r>
+          </a:p>
+        </p:txBody>
+      </p:sp>
+      <p:sp>
+        <p:nvSpPr>
+          <p:cNvPr id="15" name="TextBox 14"/>
+          <p:cNvSpPr txBox="1"/>
+          <p:nvPr/>
+        </p:nvSpPr>
+        <p:spPr>
+          <a:xfrm>
+            <a:off x="1234440" y="3593592"/>
+            <a:ext cx="10241280" cy="914400"/>
           </a:xfrm>
           <a:prstGeom prst="rect">
             <a:avLst/>
@@ -8289,36 +8724,36 @@
               </a:spcAft>
             </a:pPr>
             <a:r>
-              <a:rPr sz="2100" b="1" i="0">
+              <a:rPr sz="1850" b="1" i="0">
                 <a:solidFill>
                   <a:srgbClr val="F4F7FC"/>
                 </a:solidFill>
                 <a:latin typeface="Arial"/>
               </a:rPr>
-              <a:t>Play the hand.  </a:t>
-            </a:r>
-            <a:r>
-              <a:rPr sz="1500" b="0" i="0">
+              <a:t>Finish the shopping: a reliever and innings.  </a:t>
+            </a:r>
+            <a:r>
+              <a:rPr sz="1350" b="0" i="0">
                 <a:solidFill>
                   <a:srgbClr val="CDD4E2"/>
                 </a:solidFill>
                 <a:latin typeface="Arial"/>
               </a:rPr>
-              <a:t>77% playoff odds, +41 run differential, a wild card in hand, buy small (a reliever first), keep the vets, and let the record keep catching up to the process.</a:t>
-            </a:r>
-          </a:p>
-        </p:txBody>
-      </p:sp>
-      <p:sp>
-        <p:nvSpPr>
-          <p:cNvPr id="6" name="Rounded Rectangle 5"/>
+              <a:t>A Weaver-class arm for prospects and a Wacha-class starter for a flier. Nobody in the room loses a job; two quiet wins get covered.</a:t>
+            </a:r>
+          </a:p>
+        </p:txBody>
+      </p:sp>
+      <p:sp>
+        <p:nvSpPr>
+          <p:cNvPr id="16" name="Rounded Rectangle 15"/>
           <p:cNvSpPr/>
           <p:nvPr/>
         </p:nvSpPr>
         <p:spPr>
           <a:xfrm>
-            <a:off x="640080" y="3072384"/>
-            <a:ext cx="164592" cy="164592"/>
+            <a:off x="640080" y="4526279"/>
+            <a:ext cx="384048" cy="384048"/>
           </a:xfrm>
           <a:prstGeom prst="roundRect">
             <a:avLst>
@@ -8348,23 +8783,32 @@
           </a:fontRef>
         </p:style>
         <p:txBody>
-          <a:bodyPr rtlCol="0" anchor="ctr"/>
+          <a:bodyPr rtlCol="0" anchor="ctr" wrap="none"/>
           <a:lstStyle/>
           <a:p>
             <a:pPr algn="ctr"/>
-          </a:p>
-        </p:txBody>
-      </p:sp>
-      <p:sp>
-        <p:nvSpPr>
-          <p:cNvPr id="7" name="TextBox 6"/>
-          <p:cNvSpPr txBox="1"/>
-          <p:nvPr/>
-        </p:nvSpPr>
-        <p:spPr>
-          <a:xfrm>
-            <a:off x="960120" y="3017520"/>
-            <a:ext cx="10424160" cy="914400"/>
+            <a:r>
+              <a:rPr sz="1600" b="1">
+                <a:solidFill>
+                  <a:srgbClr val="0B1220"/>
+                </a:solidFill>
+                <a:latin typeface="Courier New"/>
+              </a:rPr>
+              <a:t>2</a:t>
+            </a:r>
+          </a:p>
+        </p:txBody>
+      </p:sp>
+      <p:sp>
+        <p:nvSpPr>
+          <p:cNvPr id="17" name="TextBox 16"/>
+          <p:cNvSpPr txBox="1"/>
+          <p:nvPr/>
+        </p:nvSpPr>
+        <p:spPr>
+          <a:xfrm>
+            <a:off x="1234440" y="4489704"/>
+            <a:ext cx="10241280" cy="914400"/>
           </a:xfrm>
           <a:prstGeom prst="rect">
             <a:avLst/>
@@ -8386,36 +8830,36 @@
               </a:spcAft>
             </a:pPr>
             <a:r>
-              <a:rPr sz="2100" b="1" i="0">
+              <a:rPr sz="1850" b="1" i="0">
                 <a:solidFill>
                   <a:srgbClr val="F4F7FC"/>
                 </a:solidFill>
                 <a:latin typeface="Arial"/>
               </a:rPr>
-              <a:t>Cash the surplus, not the slump.  </a:t>
-            </a:r>
-            <a:r>
-              <a:rPr sz="1500" b="0" i="0">
+              <a:t>Trust the diagnosis, not the heater.  </a:t>
+            </a:r>
+            <a:r>
+              <a:rPr sz="1350" b="0" i="0">
                 <a:solidFill>
                   <a:srgbClr val="CDD4E2"/>
                 </a:solidFill>
                 <a:latin typeface="Arial"/>
               </a:rPr>
-              <a:t>Hold Duran through the deadline; re-price him in winter, extend or trade the 2025 player, never the unlucky 2026 one.</a:t>
-            </a:r>
-          </a:p>
-        </p:txBody>
-      </p:sp>
-      <p:sp>
-        <p:nvSpPr>
-          <p:cNvPr id="8" name="Rounded Rectangle 7"/>
+              <a:t>The regression watch says plan for the fade. Mead, the returning injured bats, and Duran's own regression are the real September lineup.</a:t>
+            </a:r>
+          </a:p>
+        </p:txBody>
+      </p:sp>
+      <p:sp>
+        <p:nvSpPr>
+          <p:cNvPr id="18" name="Rounded Rectangle 17"/>
           <p:cNvSpPr/>
           <p:nvPr/>
         </p:nvSpPr>
         <p:spPr>
           <a:xfrm>
-            <a:off x="640080" y="4306824"/>
-            <a:ext cx="164592" cy="164592"/>
+            <a:off x="640080" y="5422392"/>
+            <a:ext cx="384048" cy="384048"/>
           </a:xfrm>
           <a:prstGeom prst="roundRect">
             <a:avLst>
@@ -8445,23 +8889,32 @@
           </a:fontRef>
         </p:style>
         <p:txBody>
-          <a:bodyPr rtlCol="0" anchor="ctr"/>
+          <a:bodyPr rtlCol="0" anchor="ctr" wrap="none"/>
           <a:lstStyle/>
           <a:p>
             <a:pPr algn="ctr"/>
-          </a:p>
-        </p:txBody>
-      </p:sp>
-      <p:sp>
-        <p:nvSpPr>
-          <p:cNvPr id="9" name="TextBox 8"/>
-          <p:cNvSpPr txBox="1"/>
-          <p:nvPr/>
-        </p:nvSpPr>
-        <p:spPr>
-          <a:xfrm>
-            <a:off x="960120" y="4251960"/>
-            <a:ext cx="10424160" cy="914400"/>
+            <a:r>
+              <a:rPr sz="1600" b="1">
+                <a:solidFill>
+                  <a:srgbClr val="0B1220"/>
+                </a:solidFill>
+                <a:latin typeface="Courier New"/>
+              </a:rPr>
+              <a:t>3</a:t>
+            </a:r>
+          </a:p>
+        </p:txBody>
+      </p:sp>
+      <p:sp>
+        <p:nvSpPr>
+          <p:cNvPr id="19" name="TextBox 18"/>
+          <p:cNvSpPr txBox="1"/>
+          <p:nvPr/>
+        </p:nvSpPr>
+        <p:spPr>
+          <a:xfrm>
+            <a:off x="1234440" y="5385816"/>
+            <a:ext cx="10241280" cy="914400"/>
           </a:xfrm>
           <a:prstGeom prst="rect">
             <a:avLst/>
@@ -8483,73 +8936,73 @@
               </a:spcAft>
             </a:pPr>
             <a:r>
-              <a:rPr sz="2100" b="1" i="0">
+              <a:rPr sz="1850" b="1" i="0">
                 <a:solidFill>
                   <a:srgbClr val="F4F7FC"/>
                 </a:solidFill>
                 <a:latin typeface="Arial"/>
               </a:rPr>
-              <a:t>Stop fighting the Yoshida deal.  </a:t>
-            </a:r>
-            <a:r>
-              <a:rPr sz="1500" b="0" i="0">
+              <a:t>Hold Duran. Decide in the winter.  </a:t>
+            </a:r>
+            <a:r>
+              <a:rPr sz="1350" b="0" i="0">
                 <a:solidFill>
                   <a:srgbClr val="CDD4E2"/>
                 </a:solidFill>
                 <a:latin typeface="Arial"/>
               </a:rPr>
-              <a:t>The bat is back to average or better; absorb the contract and let it expire.</a:t>
-            </a:r>
-          </a:p>
-        </p:txBody>
-      </p:sp>
-      <p:sp>
-        <p:nvSpPr>
-          <p:cNvPr id="10" name="TextBox 9"/>
-          <p:cNvSpPr txBox="1"/>
-          <p:nvPr/>
-        </p:nvSpPr>
-        <p:spPr>
-          <a:xfrm>
-            <a:off x="960120" y="5623560"/>
-            <a:ext cx="10424160" cy="731520"/>
-          </a:xfrm>
-          <a:prstGeom prst="rect">
-            <a:avLst/>
-          </a:prstGeom>
-          <a:noFill/>
-        </p:spPr>
-        <p:txBody>
-          <a:bodyPr wrap="square" anchor="t" lIns="0" rIns="0" tIns="0" bIns="0">
-            <a:spAutoFit/>
-          </a:bodyPr>
-          <a:lstStyle/>
-          <a:p>
-            <a:pPr algn="l">
-              <a:lnSpc>
-                <a:spcPct val="112000"/>
-              </a:lnSpc>
-              <a:spcAft>
-                <a:spcPts val="400"/>
-              </a:spcAft>
-            </a:pPr>
-            <a:r>
-              <a:rPr sz="1250" b="1" i="0">
+              <a:t>His value is at rock bottom while the underlying numbers say rebound. Buyers read xstats too; nobody pays 2024 prices in August 2026.</a:t>
+            </a:r>
+          </a:p>
+        </p:txBody>
+      </p:sp>
+      <p:sp>
+        <p:nvSpPr>
+          <p:cNvPr id="20" name="TextBox 19"/>
+          <p:cNvSpPr txBox="1"/>
+          <p:nvPr/>
+        </p:nvSpPr>
+        <p:spPr>
+          <a:xfrm>
+            <a:off x="566928" y="6263640"/>
+            <a:ext cx="11064240" cy="365760"/>
+          </a:xfrm>
+          <a:prstGeom prst="rect">
+            <a:avLst/>
+          </a:prstGeom>
+          <a:noFill/>
+        </p:spPr>
+        <p:txBody>
+          <a:bodyPr wrap="square" anchor="t" lIns="0" rIns="0" tIns="0" bIns="0">
+            <a:spAutoFit/>
+          </a:bodyPr>
+          <a:lstStyle/>
+          <a:p>
+            <a:pPr algn="l">
+              <a:lnSpc>
+                <a:spcPct val="100000"/>
+              </a:lnSpc>
+              <a:spcAft>
+                <a:spcPts val="0"/>
+              </a:spcAft>
+            </a:pPr>
+            <a:r>
+              <a:rPr sz="1150" b="0" i="1">
                 <a:solidFill>
                   <a:srgbClr val="9AA6BC"/>
                 </a:solidFill>
                 <a:latin typeface="Arial"/>
               </a:rPr>
-              <a:t>Confidence: </a:t>
-            </a:r>
-            <a:r>
-              <a:rPr sz="1250" b="0" i="1">
-                <a:solidFill>
-                  <a:srgbClr val="9AA6BC"/>
-                </a:solidFill>
-                <a:latin typeface="Arial"/>
-              </a:rPr>
-              <a:t>high that 2024 shouldn't be the anchor and pitching is a strength; the open question is how much of 2026's skill dip (chase, whiff, hard-hit are all worse) persists, the one thing to watch before selling.</a:t>
+              <a:t>Every number on these slides regenerates from live data. Predictions frozen July 4, graded in October, flattering or not.  </a:t>
+            </a:r>
+            <a:r>
+              <a:rPr sz="1150" b="1" i="0">
+                <a:solidFill>
+                  <a:srgbClr val="E8615A"/>
+                </a:solidFill>
+                <a:latin typeface="Courier New"/>
+              </a:rPr>
+              <a:t>justinloo12.github.io/red-sox-trade-deadline-thoughts</a:t>
             </a:r>
           </a:p>
         </p:txBody>
@@ -8659,7 +9112,7 @@
                 </a:solidFill>
                 <a:latin typeface="Arial"/>
               </a:rPr>
-              <a:t>A contender by run differential</a:t>
+              <a:t>Red Sox Are Back From The Dead</a:t>
             </a:r>
           </a:p>
         </p:txBody>
@@ -9411,7 +9864,7 @@
                 </a:solidFill>
                 <a:latin typeface="Arial"/>
               </a:rPr>
-              <a:t>Buy, but keep it small</a:t>
+              <a:t>Buy, Nibble At The Edges</a:t>
             </a:r>
           </a:p>
         </p:txBody>
@@ -9917,7 +10370,7 @@
                 </a:solidFill>
                 <a:latin typeface="Arial"/>
               </a:rPr>
-              <a:t>The young, cheap, controllable outfield core</a:t>
+              <a:t>Young, Controllable Outfield Core</a:t>
             </a:r>
           </a:p>
         </p:txBody>
@@ -11875,7 +12328,7 @@
                 </a:solidFill>
                 <a:latin typeface="Arial"/>
               </a:rPr>
-              <a:t>Duran's 2026 is unlucky</a:t>
+              <a:t>Duran's 2026 Is Unlucky</a:t>
             </a:r>
           </a:p>
         </p:txBody>
@@ -12530,7 +12983,7 @@
                 </a:solidFill>
                 <a:latin typeface="Arial"/>
               </a:rPr>
-              <a:t>The rebound is likely for Duran</a:t>
+              <a:t>Duran Will Be Back</a:t>
             </a:r>
           </a:p>
         </p:txBody>
@@ -13008,7 +13461,7 @@
                 </a:solidFill>
                 <a:latin typeface="Arial"/>
               </a:rPr>
-              <a:t>Swing Stats</a:t>
+              <a:t>Duran Swing Stats</a:t>
             </a:r>
           </a:p>
         </p:txBody>
@@ -13616,7 +14069,7 @@
                 </a:solidFill>
                 <a:latin typeface="Arial"/>
               </a:rPr>
-              <a:t>Aging doesn't explain the drop</a:t>
+              <a:t>Aging Not A Factor For Jarren</a:t>
             </a:r>
           </a:p>
         </p:txBody>

</xml_diff>

<commit_message>
Consistency port plus a second prediction vintage frozen at the deadline
- Goodman and the Mayer/Arias blocking note ported from the deck into
  the article and trades memo so every surface tells the same story
- New outputs/predictions_deadline.json, frozen 2026-07-26: playoff
  odds as a Brier call, the Mead earned-breakout claim (.330+ wOBA as
  a Red Sox), the AAAA-five fade, the Contreras and Gray fades with
  base-rate rationale, and the restated Duran BABIP rebound. The July
  4 file is untouched by design: pre-registrations never update, that
  is the whole point
- Closer slide credits both vintages

Co-Authored-By: Claude Fable 5 <noreply@anthropic.com>
</commit_message>
<xml_diff>
--- a/outputs/Red_Sox_Trade_Deadline.pptx
+++ b/outputs/Red_Sox_Trade_Deadline.pptx
@@ -8339,7 +8339,7 @@
                 </a:solidFill>
                 <a:latin typeface="Courier New"/>
               </a:rPr>
-              <a:t>77%</a:t>
+              <a:t>78%</a:t>
             </a:r>
           </a:p>
         </p:txBody>
@@ -8993,7 +8993,7 @@
                 </a:solidFill>
                 <a:latin typeface="Arial"/>
               </a:rPr>
-              <a:t>Every number on these slides regenerates from live data. Predictions frozen July 4, graded in October, flattering or not.  </a:t>
+              <a:t>Every number on these slides regenerates from live data. Predictions frozen July 4 and July 26, graded in October, flattering or not.  </a:t>
             </a:r>
             <a:r>
               <a:rPr sz="1150" b="1" i="0">
@@ -9550,7 +9550,7 @@
                 </a:solidFill>
                 <a:latin typeface="Arial"/>
               </a:rPr>
-              <a:t>77%</a:t>
+              <a:t>78%</a:t>
             </a:r>
           </a:p>
         </p:txBody>

</xml_diff>